<commit_message>
PVLDB camera ready - Update README.md
</commit_message>
<xml_diff>
--- a/slide_presentation/VLDB-2025-Presentation.pptx
+++ b/slide_presentation/VLDB-2025-Presentation.pptx
@@ -229,7 +229,7 @@
           <a:p>
             <a:fld id="{0EB27F89-6F89-4D72-A243-A68B4122D611}" type="datetimeFigureOut">
               <a:rPr lang="en-AU" smtClean="0"/>
-              <a:t>2/10/2024</a:t>
+              <a:t>19/12/2024</a:t>
             </a:fld>
             <a:endParaRPr lang="en-AU"/>
           </a:p>
@@ -406,7 +406,7 @@
           <a:p>
             <a:fld id="{B9751D79-A941-472A-B86F-4C1D5FA7235B}" type="datetimeFigureOut">
               <a:rPr lang="en-AU" smtClean="0"/>
-              <a:t>2/10/2024</a:t>
+              <a:t>19/12/2024</a:t>
             </a:fld>
             <a:endParaRPr lang="en-AU"/>
           </a:p>
@@ -10794,7 +10794,7 @@
                   <a:schemeClr val="tx1"/>
                 </a:solidFill>
               </a:rPr>
-              <a:t>Date: September 1, 2025</a:t>
+              <a:t>Date: September 1-5, 2025</a:t>
             </a:r>
             <a:endParaRPr lang="en-AU" dirty="0"/>
           </a:p>
@@ -11124,12 +11124,207 @@
           </a:p>
         </p:txBody>
       </p:sp>
+      <p:sp>
+        <p:nvSpPr>
+          <p:cNvPr id="17" name="TextBox 16">
+            <a:extLst>
+              <a:ext uri="{FF2B5EF4-FFF2-40B4-BE49-F238E27FC236}">
+                <a16:creationId xmlns:a16="http://schemas.microsoft.com/office/drawing/2014/main" id="{32BFA487-9D78-583E-A54C-5A51DC2F8B58}"/>
+              </a:ext>
+            </a:extLst>
+          </p:cNvPr>
+          <p:cNvSpPr txBox="1"/>
+          <p:nvPr/>
+        </p:nvSpPr>
+        <p:spPr>
+          <a:xfrm>
+            <a:off x="684000" y="2515300"/>
+            <a:ext cx="2126579" cy="307777"/>
+          </a:xfrm>
+          <a:prstGeom prst="rect">
+            <a:avLst/>
+          </a:prstGeom>
+          <a:noFill/>
+        </p:spPr>
+        <p:txBody>
+          <a:bodyPr wrap="square" rtlCol="0">
+            <a:spAutoFit/>
+          </a:bodyPr>
+          <a:lstStyle/>
+          <a:p>
+            <a:pPr marL="285750" lvl="2" indent="-285750" defTabSz="685800">
+              <a:spcAft>
+                <a:spcPts val="600"/>
+              </a:spcAft>
+              <a:buClr>
+                <a:srgbClr val="BE830E"/>
+              </a:buClr>
+              <a:buFont typeface="Wingdings" panose="05000000000000000000" pitchFamily="2" charset="2"/>
+              <a:buChar char="Ø"/>
+              <a:defRPr/>
+            </a:pPr>
+            <a:r>
+              <a:rPr lang="en-US" sz="1400" dirty="0">
+                <a:solidFill>
+                  <a:prstClr val="black"/>
+                </a:solidFill>
+                <a:latin typeface="Public Sans Light"/>
+              </a:rPr>
+              <a:t>OAEI Conference Track</a:t>
+            </a:r>
+            <a:endParaRPr kumimoji="0" lang="en-US" sz="1400" b="0" i="0" u="none" strike="noStrike" kern="1200" cap="none" spc="0" normalizeH="0" baseline="0" noProof="0" dirty="0">
+              <a:ln>
+                <a:noFill/>
+              </a:ln>
+              <a:solidFill>
+                <a:prstClr val="black"/>
+              </a:solidFill>
+              <a:effectLst/>
+              <a:uLnTx/>
+              <a:uFillTx/>
+              <a:latin typeface="Public Sans Light"/>
+              <a:ea typeface="+mn-ea"/>
+              <a:cs typeface="+mn-cs"/>
+            </a:endParaRPr>
+          </a:p>
+        </p:txBody>
+      </p:sp>
+      <p:sp>
+        <p:nvSpPr>
+          <p:cNvPr id="19" name="TextBox 18">
+            <a:extLst>
+              <a:ext uri="{FF2B5EF4-FFF2-40B4-BE49-F238E27FC236}">
+                <a16:creationId xmlns:a16="http://schemas.microsoft.com/office/drawing/2014/main" id="{617B1C3E-B6C9-8D37-1291-F88A75556307}"/>
+              </a:ext>
+            </a:extLst>
+          </p:cNvPr>
+          <p:cNvSpPr txBox="1"/>
+          <p:nvPr/>
+        </p:nvSpPr>
+        <p:spPr>
+          <a:xfrm>
+            <a:off x="4868934" y="2533258"/>
+            <a:ext cx="2126579" cy="307777"/>
+          </a:xfrm>
+          <a:prstGeom prst="rect">
+            <a:avLst/>
+          </a:prstGeom>
+          <a:noFill/>
+        </p:spPr>
+        <p:txBody>
+          <a:bodyPr wrap="square" rtlCol="0">
+            <a:spAutoFit/>
+          </a:bodyPr>
+          <a:lstStyle/>
+          <a:p>
+            <a:pPr marL="285750" lvl="2" indent="-285750" defTabSz="685800">
+              <a:spcAft>
+                <a:spcPts val="600"/>
+              </a:spcAft>
+              <a:buClr>
+                <a:srgbClr val="BE830E"/>
+              </a:buClr>
+              <a:buFont typeface="Wingdings" panose="05000000000000000000" pitchFamily="2" charset="2"/>
+              <a:buChar char="Ø"/>
+              <a:defRPr/>
+            </a:pPr>
+            <a:r>
+              <a:rPr lang="en-US" sz="1400" dirty="0">
+                <a:solidFill>
+                  <a:prstClr val="black"/>
+                </a:solidFill>
+                <a:latin typeface="Public Sans Light"/>
+              </a:rPr>
+              <a:t>OAEI Anatomy Track</a:t>
+            </a:r>
+            <a:endParaRPr kumimoji="0" lang="en-US" sz="1400" b="0" i="0" u="none" strike="noStrike" kern="1200" cap="none" spc="0" normalizeH="0" baseline="0" noProof="0" dirty="0">
+              <a:ln>
+                <a:noFill/>
+              </a:ln>
+              <a:solidFill>
+                <a:prstClr val="black"/>
+              </a:solidFill>
+              <a:effectLst/>
+              <a:uLnTx/>
+              <a:uFillTx/>
+              <a:latin typeface="Public Sans Light"/>
+              <a:ea typeface="+mn-ea"/>
+              <a:cs typeface="+mn-cs"/>
+            </a:endParaRPr>
+          </a:p>
+        </p:txBody>
+      </p:sp>
+      <p:sp>
+        <p:nvSpPr>
+          <p:cNvPr id="20" name="TextBox 19">
+            <a:extLst>
+              <a:ext uri="{FF2B5EF4-FFF2-40B4-BE49-F238E27FC236}">
+                <a16:creationId xmlns:a16="http://schemas.microsoft.com/office/drawing/2014/main" id="{5FFD7156-5F41-E10E-0C2A-35D801A1483B}"/>
+              </a:ext>
+            </a:extLst>
+          </p:cNvPr>
+          <p:cNvSpPr txBox="1"/>
+          <p:nvPr/>
+        </p:nvSpPr>
+        <p:spPr>
+          <a:xfrm>
+            <a:off x="3508710" y="4386339"/>
+            <a:ext cx="2126579" cy="307777"/>
+          </a:xfrm>
+          <a:prstGeom prst="rect">
+            <a:avLst/>
+          </a:prstGeom>
+          <a:noFill/>
+        </p:spPr>
+        <p:txBody>
+          <a:bodyPr wrap="square" rtlCol="0">
+            <a:spAutoFit/>
+          </a:bodyPr>
+          <a:lstStyle/>
+          <a:p>
+            <a:pPr marL="285750" lvl="2" indent="-285750" defTabSz="685800">
+              <a:spcAft>
+                <a:spcPts val="600"/>
+              </a:spcAft>
+              <a:buClr>
+                <a:srgbClr val="BE830E"/>
+              </a:buClr>
+              <a:buFont typeface="Wingdings" panose="05000000000000000000" pitchFamily="2" charset="2"/>
+              <a:buChar char="Ø"/>
+              <a:defRPr/>
+            </a:pPr>
+            <a:r>
+              <a:rPr lang="en-US" sz="1400" dirty="0">
+                <a:solidFill>
+                  <a:prstClr val="black"/>
+                </a:solidFill>
+                <a:latin typeface="Public Sans Light"/>
+              </a:rPr>
+              <a:t>OAEI MSE Track</a:t>
+            </a:r>
+            <a:endParaRPr kumimoji="0" lang="en-US" sz="1400" b="0" i="0" u="none" strike="noStrike" kern="1200" cap="none" spc="0" normalizeH="0" baseline="0" noProof="0" dirty="0">
+              <a:ln>
+                <a:noFill/>
+              </a:ln>
+              <a:solidFill>
+                <a:prstClr val="black"/>
+              </a:solidFill>
+              <a:effectLst/>
+              <a:uLnTx/>
+              <a:uFillTx/>
+              <a:latin typeface="Public Sans Light"/>
+              <a:ea typeface="+mn-ea"/>
+              <a:cs typeface="+mn-cs"/>
+            </a:endParaRPr>
+          </a:p>
+        </p:txBody>
+      </p:sp>
       <p:pic>
         <p:nvPicPr>
-          <p:cNvPr id="3" name="Picture 2" descr="A graph of different colored lines&#10;&#10;Description automatically generated with medium confidence">
+          <p:cNvPr id="6" name="Picture 5" descr="A graph of different colored triangles&#10;&#10;Description automatically generated with medium confidence">
             <a:extLst>
               <a:ext uri="{FF2B5EF4-FFF2-40B4-BE49-F238E27FC236}">
-                <a16:creationId xmlns:a16="http://schemas.microsoft.com/office/drawing/2014/main" id="{69A7E3E6-3E8A-B62E-499B-3C98E8A0303B}"/>
+                <a16:creationId xmlns:a16="http://schemas.microsoft.com/office/drawing/2014/main" id="{4C7848E9-6C3A-FC22-A073-917FAC53C06A}"/>
               </a:ext>
             </a:extLst>
           </p:cNvPr>
@@ -11152,8 +11347,8 @@
         </p:blipFill>
         <p:spPr>
           <a:xfrm>
-            <a:off x="3022785" y="962270"/>
-            <a:ext cx="2943455" cy="1548514"/>
+            <a:off x="64026" y="812858"/>
+            <a:ext cx="2879797" cy="1591139"/>
           </a:xfrm>
           <a:prstGeom prst="rect">
             <a:avLst/>
@@ -11162,10 +11357,10 @@
       </p:pic>
       <p:pic>
         <p:nvPicPr>
-          <p:cNvPr id="8" name="Picture 7" descr="A graph of different colored triangles&#10;&#10;Description automatically generated with medium confidence">
+          <p:cNvPr id="11" name="Picture 10" descr="A graph of different colored lines&#10;&#10;Description automatically generated with medium confidence">
             <a:extLst>
               <a:ext uri="{FF2B5EF4-FFF2-40B4-BE49-F238E27FC236}">
-                <a16:creationId xmlns:a16="http://schemas.microsoft.com/office/drawing/2014/main" id="{AA8BDF6B-C95D-D310-3388-24853BAEED86}"/>
+                <a16:creationId xmlns:a16="http://schemas.microsoft.com/office/drawing/2014/main" id="{20252DC5-E59F-48C8-EBA5-233FC67D3AEB}"/>
               </a:ext>
             </a:extLst>
           </p:cNvPr>
@@ -11188,8 +11383,8 @@
         </p:blipFill>
         <p:spPr>
           <a:xfrm>
-            <a:off x="6121216" y="953966"/>
-            <a:ext cx="2943455" cy="1548514"/>
+            <a:off x="2999674" y="819306"/>
+            <a:ext cx="3012224" cy="1584691"/>
           </a:xfrm>
           <a:prstGeom prst="rect">
             <a:avLst/>
@@ -11198,10 +11393,10 @@
       </p:pic>
       <p:pic>
         <p:nvPicPr>
-          <p:cNvPr id="10" name="Picture 9" descr="A graph of different colored triangles&#10;&#10;Description automatically generated with medium confidence">
+          <p:cNvPr id="15" name="Picture 14" descr="A graph of different colored triangles&#10;&#10;Description automatically generated with medium confidence">
             <a:extLst>
               <a:ext uri="{FF2B5EF4-FFF2-40B4-BE49-F238E27FC236}">
-                <a16:creationId xmlns:a16="http://schemas.microsoft.com/office/drawing/2014/main" id="{A372A482-9B6A-73A9-E6E4-40DB232CB7FE}"/>
+                <a16:creationId xmlns:a16="http://schemas.microsoft.com/office/drawing/2014/main" id="{32DE83C3-7E99-4B45-F36F-C2A19DF5DA36}"/>
               </a:ext>
             </a:extLst>
           </p:cNvPr>
@@ -11224,8 +11419,8 @@
         </p:blipFill>
         <p:spPr>
           <a:xfrm>
-            <a:off x="162634" y="953106"/>
-            <a:ext cx="2766075" cy="1528306"/>
+            <a:off x="6067750" y="812858"/>
+            <a:ext cx="3012224" cy="1584691"/>
           </a:xfrm>
           <a:prstGeom prst="rect">
             <a:avLst/>
@@ -11234,10 +11429,10 @@
       </p:pic>
       <p:pic>
         <p:nvPicPr>
-          <p:cNvPr id="12" name="Picture 11" descr="A graph of different colored lines&#10;&#10;Description automatically generated with medium confidence">
+          <p:cNvPr id="21" name="Picture 20" descr="A graph of different colored lines&#10;&#10;Description automatically generated with medium confidence">
             <a:extLst>
               <a:ext uri="{FF2B5EF4-FFF2-40B4-BE49-F238E27FC236}">
-                <a16:creationId xmlns:a16="http://schemas.microsoft.com/office/drawing/2014/main" id="{8F9798C4-A38E-EF57-9D8E-932500FBBAE2}"/>
+                <a16:creationId xmlns:a16="http://schemas.microsoft.com/office/drawing/2014/main" id="{F082E523-528A-2C57-56E9-9C353DCAD415}"/>
               </a:ext>
             </a:extLst>
           </p:cNvPr>
@@ -11260,8 +11455,8 @@
         </p:blipFill>
         <p:spPr>
           <a:xfrm>
-            <a:off x="162634" y="3014498"/>
-            <a:ext cx="2860151" cy="1334737"/>
+            <a:off x="64026" y="2918491"/>
+            <a:ext cx="3012224" cy="1405703"/>
           </a:xfrm>
           <a:prstGeom prst="rect">
             <a:avLst/>
@@ -11270,10 +11465,10 @@
       </p:pic>
       <p:pic>
         <p:nvPicPr>
-          <p:cNvPr id="14" name="Picture 13" descr="A graph of different colored lines&#10;&#10;Description automatically generated with medium confidence">
+          <p:cNvPr id="23" name="Picture 22" descr="A graph of different colored lines&#10;&#10;Description automatically generated with medium confidence">
             <a:extLst>
               <a:ext uri="{FF2B5EF4-FFF2-40B4-BE49-F238E27FC236}">
-                <a16:creationId xmlns:a16="http://schemas.microsoft.com/office/drawing/2014/main" id="{6922264F-1E50-EEDD-A081-9C25FC0E5ED5}"/>
+                <a16:creationId xmlns:a16="http://schemas.microsoft.com/office/drawing/2014/main" id="{852368F4-3589-848B-F5E4-10C3CC02D645}"/>
               </a:ext>
             </a:extLst>
           </p:cNvPr>
@@ -11296,8 +11491,8 @@
         </p:blipFill>
         <p:spPr>
           <a:xfrm>
-            <a:off x="3059608" y="3014498"/>
-            <a:ext cx="2860150" cy="1334736"/>
+            <a:off x="3076250" y="2924937"/>
+            <a:ext cx="3012224" cy="1405705"/>
           </a:xfrm>
           <a:prstGeom prst="rect">
             <a:avLst/>
@@ -11306,10 +11501,10 @@
       </p:pic>
       <p:pic>
         <p:nvPicPr>
-          <p:cNvPr id="16" name="Picture 15" descr="A graph of different colored lines&#10;&#10;Description automatically generated with medium confidence">
+          <p:cNvPr id="25" name="Picture 24" descr="A graph of a function&#10;&#10;Description automatically generated with medium confidence">
             <a:extLst>
               <a:ext uri="{FF2B5EF4-FFF2-40B4-BE49-F238E27FC236}">
-                <a16:creationId xmlns:a16="http://schemas.microsoft.com/office/drawing/2014/main" id="{956BCBC8-C62A-9730-007E-5D1DB9A1D475}"/>
+                <a16:creationId xmlns:a16="http://schemas.microsoft.com/office/drawing/2014/main" id="{ECE224E9-9445-8D5B-DBE4-1ADDD5F220D3}"/>
               </a:ext>
             </a:extLst>
           </p:cNvPr>
@@ -11332,209 +11527,14 @@
         </p:blipFill>
         <p:spPr>
           <a:xfrm>
-            <a:off x="6045406" y="3014498"/>
-            <a:ext cx="2860149" cy="1334736"/>
+            <a:off x="6088474" y="2918489"/>
+            <a:ext cx="3012224" cy="1405705"/>
           </a:xfrm>
           <a:prstGeom prst="rect">
             <a:avLst/>
           </a:prstGeom>
         </p:spPr>
       </p:pic>
-      <p:sp>
-        <p:nvSpPr>
-          <p:cNvPr id="17" name="TextBox 16">
-            <a:extLst>
-              <a:ext uri="{FF2B5EF4-FFF2-40B4-BE49-F238E27FC236}">
-                <a16:creationId xmlns:a16="http://schemas.microsoft.com/office/drawing/2014/main" id="{32BFA487-9D78-583E-A54C-5A51DC2F8B58}"/>
-              </a:ext>
-            </a:extLst>
-          </p:cNvPr>
-          <p:cNvSpPr txBox="1"/>
-          <p:nvPr/>
-        </p:nvSpPr>
-        <p:spPr>
-          <a:xfrm>
-            <a:off x="703148" y="2559431"/>
-            <a:ext cx="2114347" cy="307777"/>
-          </a:xfrm>
-          <a:prstGeom prst="rect">
-            <a:avLst/>
-          </a:prstGeom>
-          <a:noFill/>
-        </p:spPr>
-        <p:txBody>
-          <a:bodyPr wrap="square" rtlCol="0">
-            <a:spAutoFit/>
-          </a:bodyPr>
-          <a:lstStyle/>
-          <a:p>
-            <a:pPr marL="285750" lvl="2" indent="-285750" defTabSz="685800">
-              <a:spcAft>
-                <a:spcPts val="600"/>
-              </a:spcAft>
-              <a:buClr>
-                <a:srgbClr val="BE830E"/>
-              </a:buClr>
-              <a:buFont typeface="Wingdings" panose="05000000000000000000" pitchFamily="2" charset="2"/>
-              <a:buChar char="Ø"/>
-              <a:defRPr/>
-            </a:pPr>
-            <a:r>
-              <a:rPr lang="en-US" sz="1400" dirty="0">
-                <a:solidFill>
-                  <a:prstClr val="black"/>
-                </a:solidFill>
-                <a:latin typeface="Public Sans Light"/>
-              </a:rPr>
-              <a:t>OAEI Conference Track</a:t>
-            </a:r>
-            <a:endParaRPr kumimoji="0" lang="en-US" sz="1400" b="0" i="0" u="none" strike="noStrike" kern="1200" cap="none" spc="0" normalizeH="0" baseline="0" noProof="0" dirty="0">
-              <a:ln>
-                <a:noFill/>
-              </a:ln>
-              <a:solidFill>
-                <a:prstClr val="black"/>
-              </a:solidFill>
-              <a:effectLst/>
-              <a:uLnTx/>
-              <a:uFillTx/>
-              <a:latin typeface="Public Sans Light"/>
-              <a:ea typeface="+mn-ea"/>
-              <a:cs typeface="+mn-cs"/>
-            </a:endParaRPr>
-          </a:p>
-        </p:txBody>
-      </p:sp>
-      <p:sp>
-        <p:nvSpPr>
-          <p:cNvPr id="19" name="TextBox 18">
-            <a:extLst>
-              <a:ext uri="{FF2B5EF4-FFF2-40B4-BE49-F238E27FC236}">
-                <a16:creationId xmlns:a16="http://schemas.microsoft.com/office/drawing/2014/main" id="{617B1C3E-B6C9-8D37-1291-F88A75556307}"/>
-              </a:ext>
-            </a:extLst>
-          </p:cNvPr>
-          <p:cNvSpPr txBox="1"/>
-          <p:nvPr/>
-        </p:nvSpPr>
-        <p:spPr>
-          <a:xfrm>
-            <a:off x="4862584" y="2568757"/>
-            <a:ext cx="2114347" cy="307777"/>
-          </a:xfrm>
-          <a:prstGeom prst="rect">
-            <a:avLst/>
-          </a:prstGeom>
-          <a:noFill/>
-        </p:spPr>
-        <p:txBody>
-          <a:bodyPr wrap="square" rtlCol="0">
-            <a:spAutoFit/>
-          </a:bodyPr>
-          <a:lstStyle/>
-          <a:p>
-            <a:pPr marL="285750" lvl="2" indent="-285750" defTabSz="685800">
-              <a:spcAft>
-                <a:spcPts val="600"/>
-              </a:spcAft>
-              <a:buClr>
-                <a:srgbClr val="BE830E"/>
-              </a:buClr>
-              <a:buFont typeface="Wingdings" panose="05000000000000000000" pitchFamily="2" charset="2"/>
-              <a:buChar char="Ø"/>
-              <a:defRPr/>
-            </a:pPr>
-            <a:r>
-              <a:rPr lang="en-US" sz="1400" dirty="0">
-                <a:solidFill>
-                  <a:prstClr val="black"/>
-                </a:solidFill>
-                <a:latin typeface="Public Sans Light"/>
-              </a:rPr>
-              <a:t>OAEI Anatomy Track</a:t>
-            </a:r>
-            <a:endParaRPr kumimoji="0" lang="en-US" sz="1400" b="0" i="0" u="none" strike="noStrike" kern="1200" cap="none" spc="0" normalizeH="0" baseline="0" noProof="0" dirty="0">
-              <a:ln>
-                <a:noFill/>
-              </a:ln>
-              <a:solidFill>
-                <a:prstClr val="black"/>
-              </a:solidFill>
-              <a:effectLst/>
-              <a:uLnTx/>
-              <a:uFillTx/>
-              <a:latin typeface="Public Sans Light"/>
-              <a:ea typeface="+mn-ea"/>
-              <a:cs typeface="+mn-cs"/>
-            </a:endParaRPr>
-          </a:p>
-        </p:txBody>
-      </p:sp>
-      <p:sp>
-        <p:nvSpPr>
-          <p:cNvPr id="20" name="TextBox 19">
-            <a:extLst>
-              <a:ext uri="{FF2B5EF4-FFF2-40B4-BE49-F238E27FC236}">
-                <a16:creationId xmlns:a16="http://schemas.microsoft.com/office/drawing/2014/main" id="{5FFD7156-5F41-E10E-0C2A-35D801A1483B}"/>
-              </a:ext>
-            </a:extLst>
-          </p:cNvPr>
-          <p:cNvSpPr txBox="1"/>
-          <p:nvPr/>
-        </p:nvSpPr>
-        <p:spPr>
-          <a:xfrm>
-            <a:off x="3514826" y="4427748"/>
-            <a:ext cx="2114347" cy="307777"/>
-          </a:xfrm>
-          <a:prstGeom prst="rect">
-            <a:avLst/>
-          </a:prstGeom>
-          <a:noFill/>
-        </p:spPr>
-        <p:txBody>
-          <a:bodyPr wrap="square" rtlCol="0">
-            <a:spAutoFit/>
-          </a:bodyPr>
-          <a:lstStyle/>
-          <a:p>
-            <a:pPr marL="285750" lvl="2" indent="-285750" defTabSz="685800">
-              <a:spcAft>
-                <a:spcPts val="600"/>
-              </a:spcAft>
-              <a:buClr>
-                <a:srgbClr val="BE830E"/>
-              </a:buClr>
-              <a:buFont typeface="Wingdings" panose="05000000000000000000" pitchFamily="2" charset="2"/>
-              <a:buChar char="Ø"/>
-              <a:defRPr/>
-            </a:pPr>
-            <a:r>
-              <a:rPr lang="en-US" sz="1400" dirty="0">
-                <a:solidFill>
-                  <a:prstClr val="black"/>
-                </a:solidFill>
-                <a:latin typeface="Public Sans Light"/>
-              </a:rPr>
-              <a:t>OAEI MSE Track</a:t>
-            </a:r>
-            <a:endParaRPr kumimoji="0" lang="en-US" sz="1400" b="0" i="0" u="none" strike="noStrike" kern="1200" cap="none" spc="0" normalizeH="0" baseline="0" noProof="0" dirty="0">
-              <a:ln>
-                <a:noFill/>
-              </a:ln>
-              <a:solidFill>
-                <a:prstClr val="black"/>
-              </a:solidFill>
-              <a:effectLst/>
-              <a:uLnTx/>
-              <a:uFillTx/>
-              <a:latin typeface="Public Sans Light"/>
-              <a:ea typeface="+mn-ea"/>
-              <a:cs typeface="+mn-cs"/>
-            </a:endParaRPr>
-          </a:p>
-        </p:txBody>
-      </p:sp>
     </p:spTree>
     <p:extLst>
       <p:ext uri="{BB962C8B-B14F-4D97-AF65-F5344CB8AC3E}">
@@ -11873,7 +11873,7 @@
         </p:nvSpPr>
         <p:spPr>
           <a:xfrm>
-            <a:off x="0" y="2434330"/>
+            <a:off x="0" y="2367297"/>
             <a:ext cx="3465718" cy="307777"/>
           </a:xfrm>
           <a:prstGeom prst="rect">
@@ -11938,7 +11938,7 @@
         </p:nvSpPr>
         <p:spPr>
           <a:xfrm>
-            <a:off x="3428617" y="2437672"/>
+            <a:off x="3453597" y="2380884"/>
             <a:ext cx="2683357" cy="307777"/>
           </a:xfrm>
           <a:prstGeom prst="rect">
@@ -12054,12 +12054,241 @@
           </a:p>
         </p:txBody>
       </p:sp>
+      <p:sp>
+        <p:nvSpPr>
+          <p:cNvPr id="30" name="TextBox 29">
+            <a:extLst>
+              <a:ext uri="{FF2B5EF4-FFF2-40B4-BE49-F238E27FC236}">
+                <a16:creationId xmlns:a16="http://schemas.microsoft.com/office/drawing/2014/main" id="{2820BEC1-CC72-9300-E1C9-EBA6E1235DB6}"/>
+              </a:ext>
+            </a:extLst>
+          </p:cNvPr>
+          <p:cNvSpPr txBox="1"/>
+          <p:nvPr/>
+        </p:nvSpPr>
+        <p:spPr>
+          <a:xfrm>
+            <a:off x="4489683" y="4399050"/>
+            <a:ext cx="3985420" cy="307777"/>
+          </a:xfrm>
+          <a:prstGeom prst="rect">
+            <a:avLst/>
+          </a:prstGeom>
+          <a:noFill/>
+        </p:spPr>
+        <p:txBody>
+          <a:bodyPr wrap="square" rtlCol="0">
+            <a:spAutoFit/>
+          </a:bodyPr>
+          <a:lstStyle/>
+          <a:p>
+            <a:pPr marL="285750" lvl="2" indent="-285750" defTabSz="685800">
+              <a:spcAft>
+                <a:spcPts val="600"/>
+              </a:spcAft>
+              <a:buClr>
+                <a:srgbClr val="BE830E"/>
+              </a:buClr>
+              <a:buFont typeface="Wingdings" panose="05000000000000000000" pitchFamily="2" charset="2"/>
+              <a:buChar char="Ø"/>
+              <a:defRPr/>
+            </a:pPr>
+            <a:r>
+              <a:rPr lang="en-US" sz="1400" dirty="0">
+                <a:solidFill>
+                  <a:prstClr val="black"/>
+                </a:solidFill>
+                <a:latin typeface="Public Sans Light"/>
+              </a:rPr>
+              <a:t>Comparison of 𝑂</a:t>
+            </a:r>
+            <a:r>
+              <a:rPr lang="en-US" sz="1200" dirty="0">
+                <a:solidFill>
+                  <a:prstClr val="black"/>
+                </a:solidFill>
+                <a:latin typeface="Public Sans Light"/>
+              </a:rPr>
+              <a:t>𝑠</a:t>
+            </a:r>
+            <a:r>
+              <a:rPr lang="en-US" sz="1400" dirty="0">
+                <a:solidFill>
+                  <a:prstClr val="black"/>
+                </a:solidFill>
+                <a:latin typeface="Public Sans Light"/>
+              </a:rPr>
+              <a:t> ⇒ 𝑂</a:t>
+            </a:r>
+            <a:r>
+              <a:rPr lang="en-US" sz="1200" dirty="0">
+                <a:solidFill>
+                  <a:prstClr val="black"/>
+                </a:solidFill>
+                <a:latin typeface="Public Sans Light"/>
+              </a:rPr>
+              <a:t>𝑡</a:t>
+            </a:r>
+            <a:r>
+              <a:rPr lang="en-US" sz="1400" dirty="0">
+                <a:solidFill>
+                  <a:prstClr val="black"/>
+                </a:solidFill>
+                <a:latin typeface="Public Sans Light"/>
+              </a:rPr>
+              <a:t>, 𝑂</a:t>
+            </a:r>
+            <a:r>
+              <a:rPr lang="en-US" sz="1200" dirty="0">
+                <a:solidFill>
+                  <a:prstClr val="black"/>
+                </a:solidFill>
+                <a:latin typeface="Public Sans Light"/>
+              </a:rPr>
+              <a:t>𝑡</a:t>
+            </a:r>
+            <a:r>
+              <a:rPr lang="en-US" sz="1400" dirty="0">
+                <a:solidFill>
+                  <a:prstClr val="black"/>
+                </a:solidFill>
+                <a:latin typeface="Public Sans Light"/>
+              </a:rPr>
+              <a:t> ⇐ 𝑂</a:t>
+            </a:r>
+            <a:r>
+              <a:rPr lang="en-US" sz="1200" dirty="0">
+                <a:solidFill>
+                  <a:prstClr val="black"/>
+                </a:solidFill>
+                <a:latin typeface="Public Sans Light"/>
+              </a:rPr>
+              <a:t>𝑠</a:t>
+            </a:r>
+            <a:r>
+              <a:rPr lang="en-US" sz="1400" dirty="0">
+                <a:solidFill>
+                  <a:prstClr val="black"/>
+                </a:solidFill>
+                <a:latin typeface="Public Sans Light"/>
+              </a:rPr>
+              <a:t> , and 𝑂</a:t>
+            </a:r>
+            <a:r>
+              <a:rPr lang="en-US" sz="1200" dirty="0">
+                <a:solidFill>
+                  <a:prstClr val="black"/>
+                </a:solidFill>
+                <a:latin typeface="Public Sans Light"/>
+              </a:rPr>
+              <a:t>𝑠</a:t>
+            </a:r>
+            <a:r>
+              <a:rPr lang="en-US" sz="1400" dirty="0">
+                <a:solidFill>
+                  <a:prstClr val="black"/>
+                </a:solidFill>
+                <a:latin typeface="Public Sans Light"/>
+              </a:rPr>
+              <a:t> ⇔ 𝑂</a:t>
+            </a:r>
+            <a:r>
+              <a:rPr lang="en-US" sz="1200" dirty="0">
+                <a:solidFill>
+                  <a:prstClr val="black"/>
+                </a:solidFill>
+                <a:latin typeface="Public Sans Light"/>
+              </a:rPr>
+              <a:t>t.</a:t>
+            </a:r>
+            <a:endParaRPr kumimoji="0" lang="en-US" sz="1400" b="0" i="0" u="none" strike="noStrike" kern="1200" cap="none" spc="0" normalizeH="0" baseline="0" noProof="0" dirty="0">
+              <a:ln>
+                <a:noFill/>
+              </a:ln>
+              <a:solidFill>
+                <a:prstClr val="black"/>
+              </a:solidFill>
+              <a:effectLst/>
+              <a:uLnTx/>
+              <a:uFillTx/>
+              <a:latin typeface="Public Sans Light"/>
+              <a:ea typeface="+mn-ea"/>
+              <a:cs typeface="+mn-cs"/>
+            </a:endParaRPr>
+          </a:p>
+        </p:txBody>
+      </p:sp>
+      <p:sp>
+        <p:nvSpPr>
+          <p:cNvPr id="33" name="TextBox 32">
+            <a:extLst>
+              <a:ext uri="{FF2B5EF4-FFF2-40B4-BE49-F238E27FC236}">
+                <a16:creationId xmlns:a16="http://schemas.microsoft.com/office/drawing/2014/main" id="{837A3582-32F4-06BA-C915-E9646D80C1B0}"/>
+              </a:ext>
+            </a:extLst>
+          </p:cNvPr>
+          <p:cNvSpPr txBox="1"/>
+          <p:nvPr/>
+        </p:nvSpPr>
+        <p:spPr>
+          <a:xfrm>
+            <a:off x="6728227" y="1934101"/>
+            <a:ext cx="2289680" cy="523220"/>
+          </a:xfrm>
+          <a:prstGeom prst="rect">
+            <a:avLst/>
+          </a:prstGeom>
+          <a:noFill/>
+        </p:spPr>
+        <p:txBody>
+          <a:bodyPr wrap="square" rtlCol="0">
+            <a:spAutoFit/>
+          </a:bodyPr>
+          <a:lstStyle/>
+          <a:p>
+            <a:pPr marL="285750" lvl="2" indent="-285750" defTabSz="685800">
+              <a:spcAft>
+                <a:spcPts val="600"/>
+              </a:spcAft>
+              <a:buClr>
+                <a:srgbClr val="BE830E"/>
+              </a:buClr>
+              <a:buFont typeface="Wingdings" panose="05000000000000000000" pitchFamily="2" charset="2"/>
+              <a:buChar char="Ø"/>
+              <a:defRPr/>
+            </a:pPr>
+            <a:r>
+              <a:rPr lang="en-US" sz="1400" dirty="0">
+                <a:solidFill>
+                  <a:prstClr val="black"/>
+                </a:solidFill>
+                <a:latin typeface="Public Sans Light"/>
+              </a:rPr>
+              <a:t>Comparison of different similarity thresholds.</a:t>
+            </a:r>
+            <a:endParaRPr kumimoji="0" lang="en-US" sz="1400" b="0" i="0" u="none" strike="noStrike" kern="1200" cap="none" spc="0" normalizeH="0" baseline="0" noProof="0" dirty="0">
+              <a:ln>
+                <a:noFill/>
+              </a:ln>
+              <a:solidFill>
+                <a:prstClr val="black"/>
+              </a:solidFill>
+              <a:effectLst/>
+              <a:uLnTx/>
+              <a:uFillTx/>
+              <a:latin typeface="Public Sans Light"/>
+              <a:ea typeface="+mn-ea"/>
+              <a:cs typeface="+mn-cs"/>
+            </a:endParaRPr>
+          </a:p>
+        </p:txBody>
+      </p:sp>
       <p:pic>
         <p:nvPicPr>
-          <p:cNvPr id="6" name="Picture 5" descr="A graph and diagram of a camera&#10;&#10;Description automatically generated with medium confidence">
+          <p:cNvPr id="3" name="Picture 2" descr="A graph of different colored lines and numbers&#10;&#10;Description automatically generated with medium confidence">
             <a:extLst>
               <a:ext uri="{FF2B5EF4-FFF2-40B4-BE49-F238E27FC236}">
-                <a16:creationId xmlns:a16="http://schemas.microsoft.com/office/drawing/2014/main" id="{9333E635-640E-A0E7-2BC7-681DF97E2B24}"/>
+                <a16:creationId xmlns:a16="http://schemas.microsoft.com/office/drawing/2014/main" id="{61B39E92-E301-A390-125A-E5A75DD8E04D}"/>
               </a:ext>
             </a:extLst>
           </p:cNvPr>
@@ -12082,8 +12311,8 @@
         </p:blipFill>
         <p:spPr>
           <a:xfrm>
-            <a:off x="203809" y="963798"/>
-            <a:ext cx="3058100" cy="1353967"/>
+            <a:off x="324000" y="787537"/>
+            <a:ext cx="2630655" cy="1499757"/>
           </a:xfrm>
           <a:prstGeom prst="rect">
             <a:avLst/>
@@ -12092,10 +12321,10 @@
       </p:pic>
       <p:pic>
         <p:nvPicPr>
-          <p:cNvPr id="11" name="Picture 10" descr="A diagram of different types of graphs&#10;&#10;Description automatically generated with medium confidence">
+          <p:cNvPr id="9" name="Picture 8" descr="A diagram of different colored circles and lines&#10;&#10;Description automatically generated with medium confidence">
             <a:extLst>
               <a:ext uri="{FF2B5EF4-FFF2-40B4-BE49-F238E27FC236}">
-                <a16:creationId xmlns:a16="http://schemas.microsoft.com/office/drawing/2014/main" id="{9ABDBA12-2AB8-BD4A-63A1-347DF2A5A6A7}"/>
+                <a16:creationId xmlns:a16="http://schemas.microsoft.com/office/drawing/2014/main" id="{55D67FEB-E59E-8463-231E-D72C03EF4DE2}"/>
               </a:ext>
             </a:extLst>
           </p:cNvPr>
@@ -12118,8 +12347,8 @@
         </p:blipFill>
         <p:spPr>
           <a:xfrm>
-            <a:off x="3306173" y="963798"/>
-            <a:ext cx="2928247" cy="1357282"/>
+            <a:off x="3275563" y="843051"/>
+            <a:ext cx="3131756" cy="1451611"/>
           </a:xfrm>
           <a:prstGeom prst="rect">
             <a:avLst/>
@@ -12128,10 +12357,10 @@
       </p:pic>
       <p:pic>
         <p:nvPicPr>
-          <p:cNvPr id="15" name="Picture 14" descr="A graph with blue and orange dots&#10;&#10;Description automatically generated">
+          <p:cNvPr id="12" name="Picture 11" descr="A line graph with numbers and lines&#10;&#10;Description automatically generated">
             <a:extLst>
               <a:ext uri="{FF2B5EF4-FFF2-40B4-BE49-F238E27FC236}">
-                <a16:creationId xmlns:a16="http://schemas.microsoft.com/office/drawing/2014/main" id="{EFEFE072-881E-F55E-97A2-4208DA5ED0D9}"/>
+                <a16:creationId xmlns:a16="http://schemas.microsoft.com/office/drawing/2014/main" id="{0D4F4A43-FC50-3DC2-23FB-98F7FA44FB5C}"/>
               </a:ext>
             </a:extLst>
           </p:cNvPr>
@@ -12154,8 +12383,8 @@
         </p:blipFill>
         <p:spPr>
           <a:xfrm>
-            <a:off x="2793291" y="2855357"/>
-            <a:ext cx="1198559" cy="1452948"/>
+            <a:off x="6513775" y="1103986"/>
+            <a:ext cx="2540971" cy="730529"/>
           </a:xfrm>
           <a:prstGeom prst="rect">
             <a:avLst/>
@@ -12164,10 +12393,10 @@
       </p:pic>
       <p:pic>
         <p:nvPicPr>
-          <p:cNvPr id="21" name="Picture 20" descr="A graph with blue and orange dots&#10;&#10;Description automatically generated">
+          <p:cNvPr id="14" name="Picture 13" descr="A graph with blue and orange dots&#10;&#10;Description automatically generated">
             <a:extLst>
               <a:ext uri="{FF2B5EF4-FFF2-40B4-BE49-F238E27FC236}">
-                <a16:creationId xmlns:a16="http://schemas.microsoft.com/office/drawing/2014/main" id="{5A5748C8-50A3-58BD-717A-B546D6E8B769}"/>
+                <a16:creationId xmlns:a16="http://schemas.microsoft.com/office/drawing/2014/main" id="{27B771A4-C911-6F50-1996-058BD8E8149B}"/>
               </a:ext>
             </a:extLst>
           </p:cNvPr>
@@ -12190,8 +12419,8 @@
         </p:blipFill>
         <p:spPr>
           <a:xfrm>
-            <a:off x="326753" y="2856923"/>
-            <a:ext cx="1188746" cy="1441052"/>
+            <a:off x="222986" y="2713055"/>
+            <a:ext cx="1381143" cy="1674284"/>
           </a:xfrm>
           <a:prstGeom prst="rect">
             <a:avLst/>
@@ -12200,10 +12429,10 @@
       </p:pic>
       <p:pic>
         <p:nvPicPr>
-          <p:cNvPr id="23" name="Picture 22" descr="A graph with blue and orange dots&#10;&#10;Description automatically generated">
+          <p:cNvPr id="18" name="Picture 17" descr="A graph with blue and orange dots&#10;&#10;Description automatically generated">
             <a:extLst>
               <a:ext uri="{FF2B5EF4-FFF2-40B4-BE49-F238E27FC236}">
-                <a16:creationId xmlns:a16="http://schemas.microsoft.com/office/drawing/2014/main" id="{CFA497AD-E2E0-C63E-FB1C-B15A4A6EAC50}"/>
+                <a16:creationId xmlns:a16="http://schemas.microsoft.com/office/drawing/2014/main" id="{903037ED-F858-A8D8-3605-C1E6293458E3}"/>
               </a:ext>
             </a:extLst>
           </p:cNvPr>
@@ -12226,8 +12455,8 @@
         </p:blipFill>
         <p:spPr>
           <a:xfrm>
-            <a:off x="1557165" y="2858361"/>
-            <a:ext cx="1194460" cy="1447978"/>
+            <a:off x="1625822" y="2731342"/>
+            <a:ext cx="1440366" cy="1675322"/>
           </a:xfrm>
           <a:prstGeom prst="rect">
             <a:avLst/>
@@ -12236,10 +12465,10 @@
       </p:pic>
       <p:pic>
         <p:nvPicPr>
-          <p:cNvPr id="25" name="Picture 24" descr="A graph with different colored dots&#10;&#10;Description automatically generated">
+          <p:cNvPr id="24" name="Picture 23" descr="A graph with blue and orange dots&#10;&#10;Description automatically generated">
             <a:extLst>
               <a:ext uri="{FF2B5EF4-FFF2-40B4-BE49-F238E27FC236}">
-                <a16:creationId xmlns:a16="http://schemas.microsoft.com/office/drawing/2014/main" id="{181E523D-A446-E86C-7834-D77CC6B19B89}"/>
+                <a16:creationId xmlns:a16="http://schemas.microsoft.com/office/drawing/2014/main" id="{4A46AFF8-FB74-D708-70F6-51FED5398D33}"/>
               </a:ext>
             </a:extLst>
           </p:cNvPr>
@@ -12262,8 +12491,8 @@
         </p:blipFill>
         <p:spPr>
           <a:xfrm>
-            <a:off x="6778036" y="2835244"/>
-            <a:ext cx="1198559" cy="1462731"/>
+            <a:off x="3066188" y="2750849"/>
+            <a:ext cx="1355325" cy="1642986"/>
           </a:xfrm>
           <a:prstGeom prst="rect">
             <a:avLst/>
@@ -12272,10 +12501,10 @@
       </p:pic>
       <p:pic>
         <p:nvPicPr>
-          <p:cNvPr id="27" name="Picture 26" descr="A graph with different colored dots&#10;&#10;Description automatically generated">
+          <p:cNvPr id="28" name="Picture 27" descr="A graph with different colored dots&#10;&#10;Description automatically generated">
             <a:extLst>
               <a:ext uri="{FF2B5EF4-FFF2-40B4-BE49-F238E27FC236}">
-                <a16:creationId xmlns:a16="http://schemas.microsoft.com/office/drawing/2014/main" id="{E00AFCD6-7A0C-3DEC-ACED-7D74993AB2D6}"/>
+                <a16:creationId xmlns:a16="http://schemas.microsoft.com/office/drawing/2014/main" id="{9A5AB67D-E5B1-5784-69E6-AF54D414D380}"/>
               </a:ext>
             </a:extLst>
           </p:cNvPr>
@@ -12298,8 +12527,8 @@
         </p:blipFill>
         <p:spPr>
           <a:xfrm>
-            <a:off x="4351144" y="2855357"/>
-            <a:ext cx="1198559" cy="1462731"/>
+            <a:off x="4525032" y="2748791"/>
+            <a:ext cx="1358458" cy="1657873"/>
           </a:xfrm>
           <a:prstGeom prst="rect">
             <a:avLst/>
@@ -12308,10 +12537,10 @@
       </p:pic>
       <p:pic>
         <p:nvPicPr>
-          <p:cNvPr id="29" name="Picture 28" descr="A graph with different colored dots&#10;&#10;Description automatically generated">
+          <p:cNvPr id="34" name="Picture 33" descr="A graph with different colored dots&#10;&#10;Description automatically generated">
             <a:extLst>
               <a:ext uri="{FF2B5EF4-FFF2-40B4-BE49-F238E27FC236}">
-                <a16:creationId xmlns:a16="http://schemas.microsoft.com/office/drawing/2014/main" id="{2737A74A-5B77-9C10-EF08-BDB80AFC9EEF}"/>
+                <a16:creationId xmlns:a16="http://schemas.microsoft.com/office/drawing/2014/main" id="{1B6DA094-B7F1-9674-CFF3-26DE513C4AA0}"/>
               </a:ext>
             </a:extLst>
           </p:cNvPr>
@@ -12334,184 +12563,20 @@
         </p:blipFill>
         <p:spPr>
           <a:xfrm>
-            <a:off x="5579477" y="2862041"/>
-            <a:ext cx="1168784" cy="1426393"/>
+            <a:off x="5967100" y="2749166"/>
+            <a:ext cx="1355325" cy="1654050"/>
           </a:xfrm>
           <a:prstGeom prst="rect">
             <a:avLst/>
           </a:prstGeom>
         </p:spPr>
       </p:pic>
-      <p:sp>
-        <p:nvSpPr>
-          <p:cNvPr id="30" name="TextBox 29">
+      <p:pic>
+        <p:nvPicPr>
+          <p:cNvPr id="36" name="Picture 35" descr="A graph with different colored dots&#10;&#10;Description automatically generated">
             <a:extLst>
               <a:ext uri="{FF2B5EF4-FFF2-40B4-BE49-F238E27FC236}">
-                <a16:creationId xmlns:a16="http://schemas.microsoft.com/office/drawing/2014/main" id="{2820BEC1-CC72-9300-E1C9-EBA6E1235DB6}"/>
-              </a:ext>
-            </a:extLst>
-          </p:cNvPr>
-          <p:cNvSpPr txBox="1"/>
-          <p:nvPr/>
-        </p:nvSpPr>
-        <p:spPr>
-          <a:xfrm>
-            <a:off x="4147286" y="4398484"/>
-            <a:ext cx="3985420" cy="307777"/>
-          </a:xfrm>
-          <a:prstGeom prst="rect">
-            <a:avLst/>
-          </a:prstGeom>
-          <a:noFill/>
-        </p:spPr>
-        <p:txBody>
-          <a:bodyPr wrap="square" rtlCol="0">
-            <a:spAutoFit/>
-          </a:bodyPr>
-          <a:lstStyle/>
-          <a:p>
-            <a:pPr marL="285750" lvl="2" indent="-285750" defTabSz="685800">
-              <a:spcAft>
-                <a:spcPts val="600"/>
-              </a:spcAft>
-              <a:buClr>
-                <a:srgbClr val="BE830E"/>
-              </a:buClr>
-              <a:buFont typeface="Wingdings" panose="05000000000000000000" pitchFamily="2" charset="2"/>
-              <a:buChar char="Ø"/>
-              <a:defRPr/>
-            </a:pPr>
-            <a:r>
-              <a:rPr lang="en-US" sz="1400" dirty="0">
-                <a:solidFill>
-                  <a:prstClr val="black"/>
-                </a:solidFill>
-                <a:latin typeface="Public Sans Light"/>
-              </a:rPr>
-              <a:t>Comparison of 𝑂</a:t>
-            </a:r>
-            <a:r>
-              <a:rPr lang="en-US" sz="1200" dirty="0">
-                <a:solidFill>
-                  <a:prstClr val="black"/>
-                </a:solidFill>
-                <a:latin typeface="Public Sans Light"/>
-              </a:rPr>
-              <a:t>𝑠</a:t>
-            </a:r>
-            <a:r>
-              <a:rPr lang="en-US" sz="1400" dirty="0">
-                <a:solidFill>
-                  <a:prstClr val="black"/>
-                </a:solidFill>
-                <a:latin typeface="Public Sans Light"/>
-              </a:rPr>
-              <a:t> ⇒ 𝑂</a:t>
-            </a:r>
-            <a:r>
-              <a:rPr lang="en-US" sz="1200" dirty="0">
-                <a:solidFill>
-                  <a:prstClr val="black"/>
-                </a:solidFill>
-                <a:latin typeface="Public Sans Light"/>
-              </a:rPr>
-              <a:t>𝑡</a:t>
-            </a:r>
-            <a:r>
-              <a:rPr lang="en-US" sz="1400" dirty="0">
-                <a:solidFill>
-                  <a:prstClr val="black"/>
-                </a:solidFill>
-                <a:latin typeface="Public Sans Light"/>
-              </a:rPr>
-              <a:t>, 𝑂</a:t>
-            </a:r>
-            <a:r>
-              <a:rPr lang="en-US" sz="1200" dirty="0">
-                <a:solidFill>
-                  <a:prstClr val="black"/>
-                </a:solidFill>
-                <a:latin typeface="Public Sans Light"/>
-              </a:rPr>
-              <a:t>𝑡</a:t>
-            </a:r>
-            <a:r>
-              <a:rPr lang="en-US" sz="1400" dirty="0">
-                <a:solidFill>
-                  <a:prstClr val="black"/>
-                </a:solidFill>
-                <a:latin typeface="Public Sans Light"/>
-              </a:rPr>
-              <a:t> ⇐ 𝑂</a:t>
-            </a:r>
-            <a:r>
-              <a:rPr lang="en-US" sz="1200" dirty="0">
-                <a:solidFill>
-                  <a:prstClr val="black"/>
-                </a:solidFill>
-                <a:latin typeface="Public Sans Light"/>
-              </a:rPr>
-              <a:t>𝑠</a:t>
-            </a:r>
-            <a:r>
-              <a:rPr lang="en-US" sz="1400" dirty="0">
-                <a:solidFill>
-                  <a:prstClr val="black"/>
-                </a:solidFill>
-                <a:latin typeface="Public Sans Light"/>
-              </a:rPr>
-              <a:t> , and 𝑂</a:t>
-            </a:r>
-            <a:r>
-              <a:rPr lang="en-US" sz="1200" dirty="0">
-                <a:solidFill>
-                  <a:prstClr val="black"/>
-                </a:solidFill>
-                <a:latin typeface="Public Sans Light"/>
-              </a:rPr>
-              <a:t>𝑠</a:t>
-            </a:r>
-            <a:r>
-              <a:rPr lang="en-US" sz="1400" dirty="0">
-                <a:solidFill>
-                  <a:prstClr val="black"/>
-                </a:solidFill>
-                <a:latin typeface="Public Sans Light"/>
-              </a:rPr>
-              <a:t> ⇔ 𝑂</a:t>
-            </a:r>
-            <a:r>
-              <a:rPr lang="en-US" sz="1200" dirty="0">
-                <a:solidFill>
-                  <a:prstClr val="black"/>
-                </a:solidFill>
-                <a:latin typeface="Public Sans Light"/>
-              </a:rPr>
-              <a:t>t.</a:t>
-            </a:r>
-            <a:endParaRPr kumimoji="0" lang="en-US" sz="1400" b="0" i="0" u="none" strike="noStrike" kern="1200" cap="none" spc="0" normalizeH="0" baseline="0" noProof="0" dirty="0">
-              <a:ln>
-                <a:noFill/>
-              </a:ln>
-              <a:solidFill>
-                <a:prstClr val="black"/>
-              </a:solidFill>
-              <a:effectLst/>
-              <a:uLnTx/>
-              <a:uFillTx/>
-              <a:latin typeface="Public Sans Light"/>
-              <a:ea typeface="+mn-ea"/>
-              <a:cs typeface="+mn-cs"/>
-            </a:endParaRPr>
-          </a:p>
-        </p:txBody>
-      </p:sp>
-      <p:pic>
-        <p:nvPicPr>
-          <p:cNvPr id="32" name="Picture 31" descr="A line graph with numbers and lines&#10;&#10;Description automatically generated">
-            <a:extLst>
-              <a:ext uri="{FF2B5EF4-FFF2-40B4-BE49-F238E27FC236}">
-                <a16:creationId xmlns:a16="http://schemas.microsoft.com/office/drawing/2014/main" id="{CF119DF1-50B5-99CC-17B1-1A7E0906D038}"/>
+                <a16:creationId xmlns:a16="http://schemas.microsoft.com/office/drawing/2014/main" id="{DCC76961-CC4B-706B-F38E-C37EBE16EDAE}"/>
               </a:ext>
             </a:extLst>
           </p:cNvPr>
@@ -12534,79 +12599,14 @@
         </p:blipFill>
         <p:spPr>
           <a:xfrm>
-            <a:off x="6244655" y="1210734"/>
-            <a:ext cx="2799798" cy="804942"/>
+            <a:off x="7481724" y="2734851"/>
+            <a:ext cx="1355325" cy="1654049"/>
           </a:xfrm>
           <a:prstGeom prst="rect">
             <a:avLst/>
           </a:prstGeom>
         </p:spPr>
       </p:pic>
-      <p:sp>
-        <p:nvSpPr>
-          <p:cNvPr id="33" name="TextBox 32">
-            <a:extLst>
-              <a:ext uri="{FF2B5EF4-FFF2-40B4-BE49-F238E27FC236}">
-                <a16:creationId xmlns:a16="http://schemas.microsoft.com/office/drawing/2014/main" id="{837A3582-32F4-06BA-C915-E9646D80C1B0}"/>
-              </a:ext>
-            </a:extLst>
-          </p:cNvPr>
-          <p:cNvSpPr txBox="1"/>
-          <p:nvPr/>
-        </p:nvSpPr>
-        <p:spPr>
-          <a:xfrm>
-            <a:off x="6547369" y="2217124"/>
-            <a:ext cx="2289680" cy="523220"/>
-          </a:xfrm>
-          <a:prstGeom prst="rect">
-            <a:avLst/>
-          </a:prstGeom>
-          <a:noFill/>
-        </p:spPr>
-        <p:txBody>
-          <a:bodyPr wrap="square" rtlCol="0">
-            <a:spAutoFit/>
-          </a:bodyPr>
-          <a:lstStyle/>
-          <a:p>
-            <a:pPr marL="285750" lvl="2" indent="-285750" defTabSz="685800">
-              <a:spcAft>
-                <a:spcPts val="600"/>
-              </a:spcAft>
-              <a:buClr>
-                <a:srgbClr val="BE830E"/>
-              </a:buClr>
-              <a:buFont typeface="Wingdings" panose="05000000000000000000" pitchFamily="2" charset="2"/>
-              <a:buChar char="Ø"/>
-              <a:defRPr/>
-            </a:pPr>
-            <a:r>
-              <a:rPr lang="en-US" sz="1400" dirty="0">
-                <a:solidFill>
-                  <a:prstClr val="black"/>
-                </a:solidFill>
-                <a:latin typeface="Public Sans Light"/>
-              </a:rPr>
-              <a:t>Comparison of different similarity thresholds.</a:t>
-            </a:r>
-            <a:endParaRPr kumimoji="0" lang="en-US" sz="1400" b="0" i="0" u="none" strike="noStrike" kern="1200" cap="none" spc="0" normalizeH="0" baseline="0" noProof="0" dirty="0">
-              <a:ln>
-                <a:noFill/>
-              </a:ln>
-              <a:solidFill>
-                <a:prstClr val="black"/>
-              </a:solidFill>
-              <a:effectLst/>
-              <a:uLnTx/>
-              <a:uFillTx/>
-              <a:latin typeface="Public Sans Light"/>
-              <a:ea typeface="+mn-ea"/>
-              <a:cs typeface="+mn-cs"/>
-            </a:endParaRPr>
-          </a:p>
-        </p:txBody>
-      </p:sp>
     </p:spTree>
     <p:extLst>
       <p:ext uri="{BB962C8B-B14F-4D97-AF65-F5344CB8AC3E}">
@@ -17836,8 +17836,8 @@
         </p:nvSpPr>
         <p:spPr>
           <a:xfrm>
-            <a:off x="283990" y="816260"/>
-            <a:ext cx="8488535" cy="1461939"/>
+            <a:off x="6350" y="794676"/>
+            <a:ext cx="9137650" cy="1538883"/>
           </a:xfrm>
           <a:prstGeom prst="rect">
             <a:avLst/>
@@ -17929,7 +17929,7 @@
                 <a:ea typeface="+mn-ea"/>
                 <a:cs typeface="+mn-cs"/>
               </a:rPr>
-              <a:t>A LLM acts as a central “brain” to link different modules and instruct their functions via prompt engineering.</a:t>
+              <a:t>A LLM acts as a central “brain” to link different modules and instruct their functions via prompt engineering</a:t>
             </a:r>
           </a:p>
           <a:p>
@@ -17967,7 +17967,7 @@
                 <a:ea typeface="+mn-ea"/>
                 <a:cs typeface="+mn-cs"/>
               </a:rPr>
-              <a:t>A pair of planning modules that use </a:t>
+              <a:t>A pair of planning modules use </a:t>
             </a:r>
             <a:r>
               <a:rPr kumimoji="0" lang="en-US" sz="1400" b="0" i="0" u="none" strike="noStrike" kern="1200" cap="none" spc="0" normalizeH="0" baseline="0" noProof="0" dirty="0" err="1">
@@ -18001,7 +18001,7 @@
                 <a:ea typeface="+mn-ea"/>
                 <a:cs typeface="+mn-cs"/>
               </a:rPr>
-              <a:t> for OM decomposition.</a:t>
+              <a:t> for OM decomposition</a:t>
             </a:r>
           </a:p>
           <a:p>
@@ -18039,95 +18039,7 @@
                 <a:ea typeface="+mn-ea"/>
                 <a:cs typeface="+mn-cs"/>
               </a:rPr>
-              <a:t>A shared memory module that uses dialogue and hybrid data storage to support the search and retrieval of entity mappings.</a:t>
-            </a:r>
-            <a:endParaRPr kumimoji="0" lang="en-AU" sz="1400" b="0" i="0" u="none" strike="noStrike" kern="1200" cap="none" spc="0" normalizeH="0" baseline="0" noProof="0" dirty="0">
-              <a:ln>
-                <a:noFill/>
-              </a:ln>
-              <a:solidFill>
-                <a:prstClr val="black"/>
-              </a:solidFill>
-              <a:effectLst/>
-              <a:uLnTx/>
-              <a:uFillTx/>
-              <a:latin typeface="Public Sans Light"/>
-              <a:ea typeface="+mn-ea"/>
-              <a:cs typeface="+mn-cs"/>
-            </a:endParaRPr>
-          </a:p>
-        </p:txBody>
-      </p:sp>
-      <p:sp>
-        <p:nvSpPr>
-          <p:cNvPr id="3" name="TextBox 2">
-            <a:extLst>
-              <a:ext uri="{FF2B5EF4-FFF2-40B4-BE49-F238E27FC236}">
-                <a16:creationId xmlns:a16="http://schemas.microsoft.com/office/drawing/2014/main" id="{C239313C-C9AE-CDC0-91C3-7D2B596A4295}"/>
-              </a:ext>
-            </a:extLst>
-          </p:cNvPr>
-          <p:cNvSpPr txBox="1"/>
-          <p:nvPr/>
-        </p:nvSpPr>
-        <p:spPr>
-          <a:xfrm>
-            <a:off x="298977" y="2299784"/>
-            <a:ext cx="8473548" cy="1246495"/>
-          </a:xfrm>
-          <a:prstGeom prst="rect">
-            <a:avLst/>
-          </a:prstGeom>
-          <a:noFill/>
-        </p:spPr>
-        <p:txBody>
-          <a:bodyPr wrap="square" rtlCol="0">
-            <a:spAutoFit/>
-          </a:bodyPr>
-          <a:lstStyle/>
-          <a:p>
-            <a:pPr marL="0" marR="0" lvl="0" indent="0" algn="l" defTabSz="685800" rtl="0" eaLnBrk="1" fontAlgn="auto" latinLnBrk="0" hangingPunct="1">
-              <a:lnSpc>
-                <a:spcPct val="100000"/>
-              </a:lnSpc>
-              <a:spcBef>
-                <a:spcPts val="0"/>
-              </a:spcBef>
-              <a:spcAft>
-                <a:spcPts val="600"/>
-              </a:spcAft>
-              <a:buClrTx/>
-              <a:buSzTx/>
-              <a:buFont typeface="Arial" panose="020B0604020202020204" pitchFamily="34" charset="0"/>
-              <a:buNone/>
-              <a:tabLst/>
-              <a:defRPr/>
-            </a:pPr>
-            <a:r>
-              <a:rPr lang="en-AU" dirty="0">
-                <a:solidFill>
-                  <a:srgbClr val="BE830E"/>
-                </a:solidFill>
-                <a:latin typeface="Public Sans"/>
-              </a:rPr>
-              <a:t>Advances</a:t>
-            </a:r>
-            <a:r>
-              <a:rPr kumimoji="0" lang="en-AU" b="0" i="0" u="none" strike="noStrike" kern="1200" cap="none" spc="0" normalizeH="0" baseline="0" noProof="0" dirty="0">
-                <a:ln>
-                  <a:noFill/>
-                </a:ln>
-                <a:solidFill>
-                  <a:srgbClr val="BE830E"/>
-                </a:solidFill>
-                <a:effectLst/>
-                <a:uLnTx/>
-                <a:uFillTx/>
-                <a:latin typeface="Public Sans"/>
-                <a:ea typeface="+mn-ea"/>
-                <a:cs typeface="+mn-cs"/>
-              </a:rPr>
-              <a:t>:</a:t>
+              <a:t>A set of OM tools use ICL/RAG to mitigate LLM hallucinations</a:t>
             </a:r>
           </a:p>
           <a:p>
@@ -18165,7 +18077,95 @@
                 <a:ea typeface="+mn-ea"/>
                 <a:cs typeface="+mn-cs"/>
               </a:rPr>
-              <a:t>Cost effective entity information retrieval</a:t>
+              <a:t>A shared memory module uses dialogue and hybrid data storage to support the search and retrieval of entity mappings.</a:t>
+            </a:r>
+            <a:endParaRPr kumimoji="0" lang="en-AU" sz="1400" b="0" i="0" u="none" strike="noStrike" kern="1200" cap="none" spc="0" normalizeH="0" baseline="0" noProof="0" dirty="0">
+              <a:ln>
+                <a:noFill/>
+              </a:ln>
+              <a:solidFill>
+                <a:prstClr val="black"/>
+              </a:solidFill>
+              <a:effectLst/>
+              <a:uLnTx/>
+              <a:uFillTx/>
+              <a:latin typeface="Public Sans Light"/>
+              <a:ea typeface="+mn-ea"/>
+              <a:cs typeface="+mn-cs"/>
+            </a:endParaRPr>
+          </a:p>
+        </p:txBody>
+      </p:sp>
+      <p:sp>
+        <p:nvSpPr>
+          <p:cNvPr id="3" name="TextBox 2">
+            <a:extLst>
+              <a:ext uri="{FF2B5EF4-FFF2-40B4-BE49-F238E27FC236}">
+                <a16:creationId xmlns:a16="http://schemas.microsoft.com/office/drawing/2014/main" id="{C239313C-C9AE-CDC0-91C3-7D2B596A4295}"/>
+              </a:ext>
+            </a:extLst>
+          </p:cNvPr>
+          <p:cNvSpPr txBox="1"/>
+          <p:nvPr/>
+        </p:nvSpPr>
+        <p:spPr>
+          <a:xfrm>
+            <a:off x="6350" y="2328122"/>
+            <a:ext cx="9137650" cy="1246495"/>
+          </a:xfrm>
+          <a:prstGeom prst="rect">
+            <a:avLst/>
+          </a:prstGeom>
+          <a:noFill/>
+        </p:spPr>
+        <p:txBody>
+          <a:bodyPr wrap="square" rtlCol="0">
+            <a:spAutoFit/>
+          </a:bodyPr>
+          <a:lstStyle/>
+          <a:p>
+            <a:pPr marL="0" marR="0" lvl="0" indent="0" algn="l" defTabSz="685800" rtl="0" eaLnBrk="1" fontAlgn="auto" latinLnBrk="0" hangingPunct="1">
+              <a:lnSpc>
+                <a:spcPct val="100000"/>
+              </a:lnSpc>
+              <a:spcBef>
+                <a:spcPts val="0"/>
+              </a:spcBef>
+              <a:spcAft>
+                <a:spcPts val="600"/>
+              </a:spcAft>
+              <a:buClrTx/>
+              <a:buSzTx/>
+              <a:buFont typeface="Arial" panose="020B0604020202020204" pitchFamily="34" charset="0"/>
+              <a:buNone/>
+              <a:tabLst/>
+              <a:defRPr/>
+            </a:pPr>
+            <a:r>
+              <a:rPr lang="en-AU" dirty="0">
+                <a:solidFill>
+                  <a:srgbClr val="BE830E"/>
+                </a:solidFill>
+                <a:latin typeface="Public Sans"/>
+              </a:rPr>
+              <a:t>Advances</a:t>
+            </a:r>
+            <a:r>
+              <a:rPr kumimoji="0" lang="en-AU" b="0" i="0" u="none" strike="noStrike" kern="1200" cap="none" spc="0" normalizeH="0" baseline="0" noProof="0" dirty="0">
+                <a:ln>
+                  <a:noFill/>
+                </a:ln>
+                <a:solidFill>
+                  <a:srgbClr val="BE830E"/>
+                </a:solidFill>
+                <a:effectLst/>
+                <a:uLnTx/>
+                <a:uFillTx/>
+                <a:latin typeface="Public Sans"/>
+                <a:ea typeface="+mn-ea"/>
+                <a:cs typeface="+mn-cs"/>
+              </a:rPr>
+              <a:t>:</a:t>
             </a:r>
           </a:p>
           <a:p>
@@ -18189,16 +18189,7 @@
               <a:defRPr/>
             </a:pPr>
             <a:r>
-              <a:rPr lang="en-US" sz="1400" dirty="0">
-                <a:solidFill>
-                  <a:prstClr val="black"/>
-                </a:solidFill>
-                <a:latin typeface="Public Sans Light"/>
-              </a:rPr>
-              <a:t>M</a:t>
-            </a:r>
-            <a:r>
-              <a:rPr kumimoji="0" lang="en-US" sz="1400" b="0" i="0" u="none" strike="noStrike" kern="1200" cap="none" spc="0" normalizeH="0" baseline="0" noProof="0" dirty="0" err="1">
+              <a:rPr kumimoji="0" lang="en-US" sz="1400" b="0" i="0" u="none" strike="noStrike" kern="1200" cap="none" spc="0" normalizeH="0" baseline="0" noProof="0" dirty="0">
                 <a:ln>
                   <a:noFill/>
                 </a:ln>
@@ -18212,24 +18203,7 @@
                 <a:ea typeface="+mn-ea"/>
                 <a:cs typeface="+mn-cs"/>
               </a:rPr>
-              <a:t>atching</a:t>
-            </a:r>
-            <a:r>
-              <a:rPr kumimoji="0" lang="en-US" sz="1400" b="0" i="0" u="none" strike="noStrike" kern="1200" cap="none" spc="0" normalizeH="0" baseline="0" noProof="0" dirty="0">
-                <a:ln>
-                  <a:noFill/>
-                </a:ln>
-                <a:solidFill>
-                  <a:prstClr val="black"/>
-                </a:solidFill>
-                <a:effectLst/>
-                <a:uLnTx/>
-                <a:uFillTx/>
-                <a:latin typeface="Public Sans Light"/>
-                <a:ea typeface="+mn-ea"/>
-                <a:cs typeface="+mn-cs"/>
-              </a:rPr>
-              <a:t> candidate selection</a:t>
+              <a:t>Cost effective entity information retrieval</a:t>
             </a:r>
           </a:p>
           <a:p>
@@ -18259,6 +18233,70 @@
                 </a:solidFill>
                 <a:latin typeface="Public Sans Light"/>
               </a:rPr>
+              <a:t>M</a:t>
+            </a:r>
+            <a:r>
+              <a:rPr kumimoji="0" lang="en-US" sz="1400" b="0" i="0" u="none" strike="noStrike" kern="1200" cap="none" spc="0" normalizeH="0" baseline="0" noProof="0" dirty="0" err="1">
+                <a:ln>
+                  <a:noFill/>
+                </a:ln>
+                <a:solidFill>
+                  <a:prstClr val="black"/>
+                </a:solidFill>
+                <a:effectLst/>
+                <a:uLnTx/>
+                <a:uFillTx/>
+                <a:latin typeface="Public Sans Light"/>
+                <a:ea typeface="+mn-ea"/>
+                <a:cs typeface="+mn-cs"/>
+              </a:rPr>
+              <a:t>atching</a:t>
+            </a:r>
+            <a:r>
+              <a:rPr kumimoji="0" lang="en-US" sz="1400" b="0" i="0" u="none" strike="noStrike" kern="1200" cap="none" spc="0" normalizeH="0" baseline="0" noProof="0" dirty="0">
+                <a:ln>
+                  <a:noFill/>
+                </a:ln>
+                <a:solidFill>
+                  <a:prstClr val="black"/>
+                </a:solidFill>
+                <a:effectLst/>
+                <a:uLnTx/>
+                <a:uFillTx/>
+                <a:latin typeface="Public Sans Light"/>
+                <a:ea typeface="+mn-ea"/>
+                <a:cs typeface="+mn-cs"/>
+              </a:rPr>
+              <a:t> candidate selection</a:t>
+            </a:r>
+          </a:p>
+          <a:p>
+            <a:pPr marL="285750" marR="0" lvl="2" indent="-285750" algn="l" defTabSz="685800" rtl="0" eaLnBrk="1" fontAlgn="auto" latinLnBrk="0" hangingPunct="1">
+              <a:lnSpc>
+                <a:spcPct val="100000"/>
+              </a:lnSpc>
+              <a:spcBef>
+                <a:spcPts val="0"/>
+              </a:spcBef>
+              <a:spcAft>
+                <a:spcPts val="600"/>
+              </a:spcAft>
+              <a:buClr>
+                <a:srgbClr val="BE830E"/>
+              </a:buClr>
+              <a:buSzTx/>
+              <a:buFont typeface="Wingdings" panose="05000000000000000000" pitchFamily="2" charset="2"/>
+              <a:buChar char="Ø"/>
+              <a:tabLst/>
+              <a:defRPr/>
+            </a:pPr>
+            <a:r>
+              <a:rPr lang="en-US" sz="1400" dirty="0">
+                <a:solidFill>
+                  <a:prstClr val="black"/>
+                </a:solidFill>
+                <a:latin typeface="Public Sans Light"/>
+              </a:rPr>
               <a:t>S</a:t>
             </a:r>
             <a:r>
@@ -18326,8 +18364,8 @@
         </p:nvSpPr>
         <p:spPr>
           <a:xfrm>
-            <a:off x="283990" y="3626462"/>
-            <a:ext cx="8488535" cy="954107"/>
+            <a:off x="6350" y="3626462"/>
+            <a:ext cx="9131300" cy="954107"/>
           </a:xfrm>
           <a:prstGeom prst="rect">
             <a:avLst/>
@@ -20817,42 +20855,6 @@
           </a:p>
         </p:txBody>
       </p:sp>
-      <p:pic>
-        <p:nvPicPr>
-          <p:cNvPr id="8" name="Picture 7" descr="Architecture of Agent-OM">
-            <a:extLst>
-              <a:ext uri="{FF2B5EF4-FFF2-40B4-BE49-F238E27FC236}">
-                <a16:creationId xmlns:a16="http://schemas.microsoft.com/office/drawing/2014/main" id="{D9E5A74B-01C6-4E5D-43D2-DA196409FF59}"/>
-              </a:ext>
-            </a:extLst>
-          </p:cNvPr>
-          <p:cNvPicPr>
-            <a:picLocks noChangeAspect="1"/>
-          </p:cNvPicPr>
-          <p:nvPr/>
-        </p:nvPicPr>
-        <p:blipFill>
-          <a:blip r:embed="rId2">
-            <a:extLst>
-              <a:ext uri="{28A0092B-C50C-407E-A947-70E740481C1C}">
-                <a14:useLocalDpi xmlns:a14="http://schemas.microsoft.com/office/drawing/2010/main" val="0"/>
-              </a:ext>
-            </a:extLst>
-          </a:blip>
-          <a:stretch>
-            <a:fillRect/>
-          </a:stretch>
-        </p:blipFill>
-        <p:spPr>
-          <a:xfrm>
-            <a:off x="263983" y="851422"/>
-            <a:ext cx="4218667" cy="3689270"/>
-          </a:xfrm>
-          <a:prstGeom prst="rect">
-            <a:avLst/>
-          </a:prstGeom>
-        </p:spPr>
-      </p:pic>
       <p:sp>
         <p:nvSpPr>
           <p:cNvPr id="10" name="TextBox 9">
@@ -21450,6 +21452,42 @@
           </a:p>
         </p:txBody>
       </p:sp>
+      <p:pic>
+        <p:nvPicPr>
+          <p:cNvPr id="6" name="Picture 5" descr="A diagram of a process&#10;&#10;Description automatically generated">
+            <a:extLst>
+              <a:ext uri="{FF2B5EF4-FFF2-40B4-BE49-F238E27FC236}">
+                <a16:creationId xmlns:a16="http://schemas.microsoft.com/office/drawing/2014/main" id="{44848642-9924-7FCA-A9EA-DF6F9D75D483}"/>
+              </a:ext>
+            </a:extLst>
+          </p:cNvPr>
+          <p:cNvPicPr>
+            <a:picLocks noChangeAspect="1"/>
+          </p:cNvPicPr>
+          <p:nvPr/>
+        </p:nvPicPr>
+        <p:blipFill>
+          <a:blip r:embed="rId2">
+            <a:extLst>
+              <a:ext uri="{28A0092B-C50C-407E-A947-70E740481C1C}">
+                <a14:useLocalDpi xmlns:a14="http://schemas.microsoft.com/office/drawing/2010/main" val="0"/>
+              </a:ext>
+            </a:extLst>
+          </a:blip>
+          <a:stretch>
+            <a:fillRect/>
+          </a:stretch>
+        </p:blipFill>
+        <p:spPr>
+          <a:xfrm>
+            <a:off x="95695" y="760096"/>
+            <a:ext cx="4569830" cy="4008054"/>
+          </a:xfrm>
+          <a:prstGeom prst="rect">
+            <a:avLst/>
+          </a:prstGeom>
+        </p:spPr>
+      </p:pic>
     </p:spTree>
     <p:extLst>
       <p:ext uri="{BB962C8B-B14F-4D97-AF65-F5344CB8AC3E}">
@@ -22882,7 +22920,7 @@
               <a:defRPr/>
             </a:pPr>
             <a:r>
-              <a:rPr kumimoji="0" lang="en-US" sz="1400" b="0" i="0" u="none" strike="noStrike" kern="1200" cap="none" spc="0" normalizeH="0" baseline="0" noProof="0" dirty="0" err="1">
+              <a:rPr kumimoji="0" lang="en-US" sz="1400" b="0" i="0" u="none" strike="noStrike" kern="1200" cap="none" spc="0" normalizeH="0" baseline="0" noProof="0" dirty="0">
                 <a:ln>
                   <a:noFill/>
                 </a:ln>
@@ -22896,16 +22934,7 @@
                 <a:ea typeface="+mn-ea"/>
                 <a:cs typeface="+mn-cs"/>
               </a:rPr>
-              <a:t>Mistra</a:t>
-            </a:r>
-            <a:r>
-              <a:rPr lang="en-US" sz="1400" dirty="0">
-                <a:solidFill>
-                  <a:prstClr val="black"/>
-                </a:solidFill>
-                <a:latin typeface="Public Sans Light"/>
-              </a:rPr>
-              <a:t>l AI: mistral-small, mistral-7b</a:t>
+              <a:t>Meta Llama: llama-3-8b, llama-3.1-8b</a:t>
             </a:r>
           </a:p>
           <a:p>
@@ -22935,7 +22964,41 @@
                 <a:ea typeface="+mn-ea"/>
                 <a:cs typeface="+mn-cs"/>
               </a:rPr>
-              <a:t>Meta Llama: llama-3-8b</a:t>
+              <a:t>Alibaba </a:t>
+            </a:r>
+            <a:r>
+              <a:rPr kumimoji="0" lang="en-US" sz="1400" b="0" i="0" u="none" strike="noStrike" kern="1200" cap="none" spc="0" normalizeH="0" baseline="0" noProof="0" dirty="0" err="1">
+                <a:ln>
+                  <a:noFill/>
+                </a:ln>
+                <a:solidFill>
+                  <a:prstClr val="black"/>
+                </a:solidFill>
+                <a:effectLst/>
+                <a:uLnTx/>
+                <a:uFillTx/>
+                <a:latin typeface="Public Sans Light"/>
+                <a:ea typeface="+mn-ea"/>
+                <a:cs typeface="+mn-cs"/>
+              </a:rPr>
+              <a:t>Qwen</a:t>
+            </a:r>
+            <a:r>
+              <a:rPr kumimoji="0" lang="en-US" sz="1400" b="0" i="0" u="none" strike="noStrike" kern="1200" cap="none" spc="0" normalizeH="0" baseline="0" noProof="0" dirty="0">
+                <a:ln>
+                  <a:noFill/>
+                </a:ln>
+                <a:solidFill>
+                  <a:prstClr val="black"/>
+                </a:solidFill>
+                <a:effectLst/>
+                <a:uLnTx/>
+                <a:uFillTx/>
+                <a:latin typeface="Public Sans Light"/>
+                <a:ea typeface="+mn-ea"/>
+                <a:cs typeface="+mn-cs"/>
+              </a:rPr>
+              <a:t>: qwen-2-7b, qwen-2.5-7b</a:t>
             </a:r>
           </a:p>
           <a:p>
@@ -22981,6 +23044,23 @@
               <a:defRPr/>
             </a:pPr>
             <a:r>
+              <a:rPr kumimoji="0" lang="en-US" sz="1400" b="0" i="0" u="none" strike="noStrike" kern="1200" cap="none" spc="0" normalizeH="0" baseline="0" noProof="0" dirty="0" err="1">
+                <a:ln>
+                  <a:noFill/>
+                </a:ln>
+                <a:solidFill>
+                  <a:prstClr val="black"/>
+                </a:solidFill>
+                <a:effectLst/>
+                <a:uLnTx/>
+                <a:uFillTx/>
+                <a:latin typeface="Public Sans Light"/>
+                <a:ea typeface="+mn-ea"/>
+                <a:cs typeface="+mn-cs"/>
+              </a:rPr>
+              <a:t>ChatGLM</a:t>
+            </a:r>
+            <a:r>
               <a:rPr kumimoji="0" lang="en-US" sz="1400" b="0" i="0" u="none" strike="noStrike" kern="1200" cap="none" spc="0" normalizeH="0" baseline="0" noProof="0" dirty="0">
                 <a:ln>
                   <a:noFill/>
@@ -22995,41 +23075,7 @@
                 <a:ea typeface="+mn-ea"/>
                 <a:cs typeface="+mn-cs"/>
               </a:rPr>
-              <a:t>Alibaba </a:t>
-            </a:r>
-            <a:r>
-              <a:rPr kumimoji="0" lang="en-US" sz="1400" b="0" i="0" u="none" strike="noStrike" kern="1200" cap="none" spc="0" normalizeH="0" baseline="0" noProof="0" dirty="0" err="1">
-                <a:ln>
-                  <a:noFill/>
-                </a:ln>
-                <a:solidFill>
-                  <a:prstClr val="black"/>
-                </a:solidFill>
-                <a:effectLst/>
-                <a:uLnTx/>
-                <a:uFillTx/>
-                <a:latin typeface="Public Sans Light"/>
-                <a:ea typeface="+mn-ea"/>
-                <a:cs typeface="+mn-cs"/>
-              </a:rPr>
-              <a:t>Qwen</a:t>
-            </a:r>
-            <a:r>
-              <a:rPr kumimoji="0" lang="en-US" sz="1400" b="0" i="0" u="none" strike="noStrike" kern="1200" cap="none" spc="0" normalizeH="0" baseline="0" noProof="0" dirty="0">
-                <a:ln>
-                  <a:noFill/>
-                </a:ln>
-                <a:solidFill>
-                  <a:prstClr val="black"/>
-                </a:solidFill>
-                <a:effectLst/>
-                <a:uLnTx/>
-                <a:uFillTx/>
-                <a:latin typeface="Public Sans Light"/>
-                <a:ea typeface="+mn-ea"/>
-                <a:cs typeface="+mn-cs"/>
-              </a:rPr>
-              <a:t>: qwen-2-7b</a:t>
+              <a:t>: glm-4-9b</a:t>
             </a:r>
           </a:p>
         </p:txBody>
@@ -25645,6 +25691,35 @@
 </file>
 
 <file path=customXml/item1.xml><?xml version="1.0" encoding="utf-8"?>
+<?mso-contentType ?>
+<FormTemplates xmlns="http://schemas.microsoft.com/sharepoint/v3/contenttype/forms">
+  <Display>DocumentLibraryForm</Display>
+  <Edit>DocumentLibraryForm</Edit>
+  <New>DocumentLibraryForm</New>
+</FormTemplates>
+</file>
+
+<file path=customXml/item2.xml><?xml version="1.0" encoding="utf-8"?>
+<p:properties xmlns:p="http://schemas.microsoft.com/office/2006/metadata/properties" xmlns:xsi="http://www.w3.org/2001/XMLSchema-instance" xmlns:pc="http://schemas.microsoft.com/office/infopath/2007/PartnerControls">
+  <documentManagement>
+    <Document_x0020_Notes xmlns="2906fbf8-e47d-4c21-be87-cb09cf1c70cb">DO NOT EDIT. DOWNLOAD FIRST.</Document_x0020_Notes>
+    <FAQs xmlns="2906fbf8-e47d-4c21-be87-cb09cf1c70cb"/>
+    <TaxCatchAll xmlns="c30e2885-58e1-4e94-9dc7-f83158e7ef28" xsi:nil="true"/>
+    <lcf76f155ced4ddcb4097134ff3c332f xmlns="2906fbf8-e47d-4c21-be87-cb09cf1c70cb">
+      <Terms xmlns="http://schemas.microsoft.com/office/infopath/2007/PartnerControls"/>
+    </lcf76f155ced4ddcb4097134ff3c332f>
+    <SharedWithUsers xmlns="cd7196b5-af4d-4b5a-ba66-d723b2d8b01e">
+      <UserInfo>
+        <DisplayName>Simon Mishricky</DisplayName>
+        <AccountId>7743</AccountId>
+        <AccountType/>
+      </UserInfo>
+    </SharedWithUsers>
+  </documentManagement>
+</p:properties>
+</file>
+
+<file path=customXml/item3.xml><?xml version="1.0" encoding="utf-8"?>
 <ct:contentTypeSchema xmlns:ct="http://schemas.microsoft.com/office/2006/metadata/contentType" xmlns:ma="http://schemas.microsoft.com/office/2006/metadata/properties/metaAttributes" ct:_="" ma:_="" ma:contentTypeName="Document" ma:contentTypeID="0x010100EF009AC5283E95468D41B3B02A942082" ma:contentTypeVersion="18" ma:contentTypeDescription="Create a new document." ma:contentTypeScope="" ma:versionID="df342da6074ddaf222b98670cd88df63">
   <xsd:schema xmlns:xsd="http://www.w3.org/2001/XMLSchema" xmlns:xs="http://www.w3.org/2001/XMLSchema" xmlns:p="http://schemas.microsoft.com/office/2006/metadata/properties" xmlns:ns2="2906fbf8-e47d-4c21-be87-cb09cf1c70cb" xmlns:ns3="cd7196b5-af4d-4b5a-ba66-d723b2d8b01e" xmlns:ns4="c30e2885-58e1-4e94-9dc7-f83158e7ef28" targetNamespace="http://schemas.microsoft.com/office/2006/metadata/properties" ma:root="true" ma:fieldsID="6e4e19e9d36c91e495a51a1636f4d0b6" ns2:_="" ns3:_="" ns4:_="">
     <xsd:import namespace="2906fbf8-e47d-4c21-be87-cb09cf1c70cb"/>
@@ -25908,51 +25983,10 @@
 </ct:contentTypeSchema>
 </file>
 
-<file path=customXml/item2.xml><?xml version="1.0" encoding="utf-8"?>
-<p:properties xmlns:p="http://schemas.microsoft.com/office/2006/metadata/properties" xmlns:xsi="http://www.w3.org/2001/XMLSchema-instance" xmlns:pc="http://schemas.microsoft.com/office/infopath/2007/PartnerControls">
-  <documentManagement>
-    <Document_x0020_Notes xmlns="2906fbf8-e47d-4c21-be87-cb09cf1c70cb">DO NOT EDIT. DOWNLOAD FIRST.</Document_x0020_Notes>
-    <FAQs xmlns="2906fbf8-e47d-4c21-be87-cb09cf1c70cb"/>
-    <TaxCatchAll xmlns="c30e2885-58e1-4e94-9dc7-f83158e7ef28" xsi:nil="true"/>
-    <lcf76f155ced4ddcb4097134ff3c332f xmlns="2906fbf8-e47d-4c21-be87-cb09cf1c70cb">
-      <Terms xmlns="http://schemas.microsoft.com/office/infopath/2007/PartnerControls"/>
-    </lcf76f155ced4ddcb4097134ff3c332f>
-    <SharedWithUsers xmlns="cd7196b5-af4d-4b5a-ba66-d723b2d8b01e">
-      <UserInfo>
-        <DisplayName>Simon Mishricky</DisplayName>
-        <AccountId>7743</AccountId>
-        <AccountType/>
-      </UserInfo>
-    </SharedWithUsers>
-  </documentManagement>
-</p:properties>
-</file>
-
-<file path=customXml/item3.xml><?xml version="1.0" encoding="utf-8"?>
-<?mso-contentType ?>
-<FormTemplates xmlns="http://schemas.microsoft.com/sharepoint/v3/contenttype/forms">
-  <Display>DocumentLibraryForm</Display>
-  <Edit>DocumentLibraryForm</Edit>
-  <New>DocumentLibraryForm</New>
-</FormTemplates>
-</file>
-
 <file path=customXml/itemProps1.xml><?xml version="1.0" encoding="utf-8"?>
-<ds:datastoreItem xmlns:ds="http://schemas.openxmlformats.org/officeDocument/2006/customXml" ds:itemID="{5AA5ED56-7671-4508-8E27-20ACB9C8341A}">
+<ds:datastoreItem xmlns:ds="http://schemas.openxmlformats.org/officeDocument/2006/customXml" ds:itemID="{D242CD11-9905-45C0-AA8E-EE5B79DEFBE2}">
   <ds:schemaRefs>
-    <ds:schemaRef ds:uri="http://schemas.microsoft.com/office/2006/metadata/contentType"/>
-    <ds:schemaRef ds:uri="http://schemas.microsoft.com/office/2006/metadata/properties/metaAttributes"/>
-    <ds:schemaRef ds:uri="http://www.w3.org/2001/XMLSchema"/>
-    <ds:schemaRef ds:uri="http://schemas.microsoft.com/office/2006/metadata/properties"/>
-    <ds:schemaRef ds:uri="2906fbf8-e47d-4c21-be87-cb09cf1c70cb"/>
-    <ds:schemaRef ds:uri="cd7196b5-af4d-4b5a-ba66-d723b2d8b01e"/>
-    <ds:schemaRef ds:uri="c30e2885-58e1-4e94-9dc7-f83158e7ef28"/>
-    <ds:schemaRef ds:uri="http://schemas.microsoft.com/office/2006/documentManagement/types"/>
-    <ds:schemaRef ds:uri="http://schemas.microsoft.com/office/infopath/2007/PartnerControls"/>
-    <ds:schemaRef ds:uri="http://schemas.openxmlformats.org/package/2006/metadata/core-properties"/>
-    <ds:schemaRef ds:uri="http://purl.org/dc/elements/1.1/"/>
-    <ds:schemaRef ds:uri="http://purl.org/dc/terms/"/>
-    <ds:schemaRef ds:uri="http://schemas.microsoft.com/internal/obd"/>
+    <ds:schemaRef ds:uri="http://schemas.microsoft.com/sharepoint/v3/contenttype/forms"/>
   </ds:schemaRefs>
 </ds:datastoreItem>
 </file>
@@ -25976,9 +26010,21 @@
 </file>
 
 <file path=customXml/itemProps3.xml><?xml version="1.0" encoding="utf-8"?>
-<ds:datastoreItem xmlns:ds="http://schemas.openxmlformats.org/officeDocument/2006/customXml" ds:itemID="{D242CD11-9905-45C0-AA8E-EE5B79DEFBE2}">
+<ds:datastoreItem xmlns:ds="http://schemas.openxmlformats.org/officeDocument/2006/customXml" ds:itemID="{5AA5ED56-7671-4508-8E27-20ACB9C8341A}">
   <ds:schemaRefs>
-    <ds:schemaRef ds:uri="http://schemas.microsoft.com/sharepoint/v3/contenttype/forms"/>
+    <ds:schemaRef ds:uri="http://schemas.microsoft.com/office/2006/metadata/contentType"/>
+    <ds:schemaRef ds:uri="http://schemas.microsoft.com/office/2006/metadata/properties/metaAttributes"/>
+    <ds:schemaRef ds:uri="http://www.w3.org/2001/XMLSchema"/>
+    <ds:schemaRef ds:uri="http://schemas.microsoft.com/office/2006/metadata/properties"/>
+    <ds:schemaRef ds:uri="2906fbf8-e47d-4c21-be87-cb09cf1c70cb"/>
+    <ds:schemaRef ds:uri="cd7196b5-af4d-4b5a-ba66-d723b2d8b01e"/>
+    <ds:schemaRef ds:uri="c30e2885-58e1-4e94-9dc7-f83158e7ef28"/>
+    <ds:schemaRef ds:uri="http://schemas.microsoft.com/office/2006/documentManagement/types"/>
+    <ds:schemaRef ds:uri="http://schemas.microsoft.com/office/infopath/2007/PartnerControls"/>
+    <ds:schemaRef ds:uri="http://schemas.openxmlformats.org/package/2006/metadata/core-properties"/>
+    <ds:schemaRef ds:uri="http://purl.org/dc/elements/1.1/"/>
+    <ds:schemaRef ds:uri="http://purl.org/dc/terms/"/>
+    <ds:schemaRef ds:uri="http://schemas.microsoft.com/internal/obd"/>
   </ds:schemaRefs>
 </ds:datastoreItem>
 </file>
</xml_diff>

<commit_message>
PVLDB camera ready - Update llm_om_only.py - Update llm_om_with_context.py
</commit_message>
<xml_diff>
--- a/slide_presentation/VLDB-2025-Presentation.pptx
+++ b/slide_presentation/VLDB-2025-Presentation.pptx
@@ -229,7 +229,7 @@
           <a:p>
             <a:fld id="{0EB27F89-6F89-4D72-A243-A68B4122D611}" type="datetimeFigureOut">
               <a:rPr lang="en-AU" smtClean="0"/>
-              <a:t>19/12/2024</a:t>
+              <a:t>21/12/2024</a:t>
             </a:fld>
             <a:endParaRPr lang="en-AU"/>
           </a:p>
@@ -406,7 +406,7 @@
           <a:p>
             <a:fld id="{B9751D79-A941-472A-B86F-4C1D5FA7235B}" type="datetimeFigureOut">
               <a:rPr lang="en-AU" smtClean="0"/>
-              <a:t>19/12/2024</a:t>
+              <a:t>21/12/2024</a:t>
             </a:fld>
             <a:endParaRPr lang="en-AU"/>
           </a:p>
@@ -11873,7 +11873,7 @@
         </p:nvSpPr>
         <p:spPr>
           <a:xfrm>
-            <a:off x="0" y="2367297"/>
+            <a:off x="222986" y="2366239"/>
             <a:ext cx="3465718" cy="307777"/>
           </a:xfrm>
           <a:prstGeom prst="rect">
@@ -11938,7 +11938,7 @@
         </p:nvSpPr>
         <p:spPr>
           <a:xfrm>
-            <a:off x="3453597" y="2380884"/>
+            <a:off x="4489683" y="2383133"/>
             <a:ext cx="2683357" cy="307777"/>
           </a:xfrm>
           <a:prstGeom prst="rect">
@@ -12200,71 +12200,6 @@
                 <a:latin typeface="Public Sans Light"/>
               </a:rPr>
               <a:t>t.</a:t>
-            </a:r>
-            <a:endParaRPr kumimoji="0" lang="en-US" sz="1400" b="0" i="0" u="none" strike="noStrike" kern="1200" cap="none" spc="0" normalizeH="0" baseline="0" noProof="0" dirty="0">
-              <a:ln>
-                <a:noFill/>
-              </a:ln>
-              <a:solidFill>
-                <a:prstClr val="black"/>
-              </a:solidFill>
-              <a:effectLst/>
-              <a:uLnTx/>
-              <a:uFillTx/>
-              <a:latin typeface="Public Sans Light"/>
-              <a:ea typeface="+mn-ea"/>
-              <a:cs typeface="+mn-cs"/>
-            </a:endParaRPr>
-          </a:p>
-        </p:txBody>
-      </p:sp>
-      <p:sp>
-        <p:nvSpPr>
-          <p:cNvPr id="33" name="TextBox 32">
-            <a:extLst>
-              <a:ext uri="{FF2B5EF4-FFF2-40B4-BE49-F238E27FC236}">
-                <a16:creationId xmlns:a16="http://schemas.microsoft.com/office/drawing/2014/main" id="{837A3582-32F4-06BA-C915-E9646D80C1B0}"/>
-              </a:ext>
-            </a:extLst>
-          </p:cNvPr>
-          <p:cNvSpPr txBox="1"/>
-          <p:nvPr/>
-        </p:nvSpPr>
-        <p:spPr>
-          <a:xfrm>
-            <a:off x="6728227" y="1934101"/>
-            <a:ext cx="2289680" cy="523220"/>
-          </a:xfrm>
-          <a:prstGeom prst="rect">
-            <a:avLst/>
-          </a:prstGeom>
-          <a:noFill/>
-        </p:spPr>
-        <p:txBody>
-          <a:bodyPr wrap="square" rtlCol="0">
-            <a:spAutoFit/>
-          </a:bodyPr>
-          <a:lstStyle/>
-          <a:p>
-            <a:pPr marL="285750" lvl="2" indent="-285750" defTabSz="685800">
-              <a:spcAft>
-                <a:spcPts val="600"/>
-              </a:spcAft>
-              <a:buClr>
-                <a:srgbClr val="BE830E"/>
-              </a:buClr>
-              <a:buFont typeface="Wingdings" panose="05000000000000000000" pitchFamily="2" charset="2"/>
-              <a:buChar char="Ø"/>
-              <a:defRPr/>
-            </a:pPr>
-            <a:r>
-              <a:rPr lang="en-US" sz="1400" dirty="0">
-                <a:solidFill>
-                  <a:prstClr val="black"/>
-                </a:solidFill>
-                <a:latin typeface="Public Sans Light"/>
-              </a:rPr>
-              <a:t>Comparison of different similarity thresholds.</a:t>
             </a:r>
             <a:endParaRPr kumimoji="0" lang="en-US" sz="1400" b="0" i="0" u="none" strike="noStrike" kern="1200" cap="none" spc="0" normalizeH="0" baseline="0" noProof="0" dirty="0">
               <a:ln>
@@ -12311,7 +12246,7 @@
         </p:blipFill>
         <p:spPr>
           <a:xfrm>
-            <a:off x="324000" y="787537"/>
+            <a:off x="844200" y="772151"/>
             <a:ext cx="2630655" cy="1499757"/>
           </a:xfrm>
           <a:prstGeom prst="rect">
@@ -12347,44 +12282,8 @@
         </p:blipFill>
         <p:spPr>
           <a:xfrm>
-            <a:off x="3275563" y="843051"/>
+            <a:off x="4489683" y="820297"/>
             <a:ext cx="3131756" cy="1451611"/>
-          </a:xfrm>
-          <a:prstGeom prst="rect">
-            <a:avLst/>
-          </a:prstGeom>
-        </p:spPr>
-      </p:pic>
-      <p:pic>
-        <p:nvPicPr>
-          <p:cNvPr id="12" name="Picture 11" descr="A line graph with numbers and lines&#10;&#10;Description automatically generated">
-            <a:extLst>
-              <a:ext uri="{FF2B5EF4-FFF2-40B4-BE49-F238E27FC236}">
-                <a16:creationId xmlns:a16="http://schemas.microsoft.com/office/drawing/2014/main" id="{0D4F4A43-FC50-3DC2-23FB-98F7FA44FB5C}"/>
-              </a:ext>
-            </a:extLst>
-          </p:cNvPr>
-          <p:cNvPicPr>
-            <a:picLocks noChangeAspect="1"/>
-          </p:cNvPicPr>
-          <p:nvPr/>
-        </p:nvPicPr>
-        <p:blipFill>
-          <a:blip r:embed="rId4">
-            <a:extLst>
-              <a:ext uri="{28A0092B-C50C-407E-A947-70E740481C1C}">
-                <a14:useLocalDpi xmlns:a14="http://schemas.microsoft.com/office/drawing/2010/main" val="0"/>
-              </a:ext>
-            </a:extLst>
-          </a:blip>
-          <a:stretch>
-            <a:fillRect/>
-          </a:stretch>
-        </p:blipFill>
-        <p:spPr>
-          <a:xfrm>
-            <a:off x="6513775" y="1103986"/>
-            <a:ext cx="2540971" cy="730529"/>
           </a:xfrm>
           <a:prstGeom prst="rect">
             <a:avLst/>
@@ -12406,7 +12305,7 @@
           <p:nvPr/>
         </p:nvPicPr>
         <p:blipFill>
-          <a:blip r:embed="rId5">
+          <a:blip r:embed="rId4">
             <a:extLst>
               <a:ext uri="{28A0092B-C50C-407E-A947-70E740481C1C}">
                 <a14:useLocalDpi xmlns:a14="http://schemas.microsoft.com/office/drawing/2010/main" val="0"/>
@@ -12442,7 +12341,7 @@
           <p:nvPr/>
         </p:nvPicPr>
         <p:blipFill>
-          <a:blip r:embed="rId6">
+          <a:blip r:embed="rId5">
             <a:extLst>
               <a:ext uri="{28A0092B-C50C-407E-A947-70E740481C1C}">
                 <a14:useLocalDpi xmlns:a14="http://schemas.microsoft.com/office/drawing/2010/main" val="0"/>
@@ -12478,7 +12377,7 @@
           <p:nvPr/>
         </p:nvPicPr>
         <p:blipFill>
-          <a:blip r:embed="rId7">
+          <a:blip r:embed="rId6">
             <a:extLst>
               <a:ext uri="{28A0092B-C50C-407E-A947-70E740481C1C}">
                 <a14:useLocalDpi xmlns:a14="http://schemas.microsoft.com/office/drawing/2010/main" val="0"/>
@@ -12514,7 +12413,7 @@
           <p:nvPr/>
         </p:nvPicPr>
         <p:blipFill>
-          <a:blip r:embed="rId8">
+          <a:blip r:embed="rId7">
             <a:extLst>
               <a:ext uri="{28A0092B-C50C-407E-A947-70E740481C1C}">
                 <a14:useLocalDpi xmlns:a14="http://schemas.microsoft.com/office/drawing/2010/main" val="0"/>
@@ -12550,7 +12449,7 @@
           <p:nvPr/>
         </p:nvPicPr>
         <p:blipFill>
-          <a:blip r:embed="rId9">
+          <a:blip r:embed="rId8">
             <a:extLst>
               <a:ext uri="{28A0092B-C50C-407E-A947-70E740481C1C}">
                 <a14:useLocalDpi xmlns:a14="http://schemas.microsoft.com/office/drawing/2010/main" val="0"/>
@@ -12586,7 +12485,7 @@
           <p:nvPr/>
         </p:nvPicPr>
         <p:blipFill>
-          <a:blip r:embed="rId10">
+          <a:blip r:embed="rId9">
             <a:extLst>
               <a:ext uri="{28A0092B-C50C-407E-A947-70E740481C1C}">
                 <a14:useLocalDpi xmlns:a14="http://schemas.microsoft.com/office/drawing/2010/main" val="0"/>
@@ -25691,35 +25590,6 @@
 </file>
 
 <file path=customXml/item1.xml><?xml version="1.0" encoding="utf-8"?>
-<?mso-contentType ?>
-<FormTemplates xmlns="http://schemas.microsoft.com/sharepoint/v3/contenttype/forms">
-  <Display>DocumentLibraryForm</Display>
-  <Edit>DocumentLibraryForm</Edit>
-  <New>DocumentLibraryForm</New>
-</FormTemplates>
-</file>
-
-<file path=customXml/item2.xml><?xml version="1.0" encoding="utf-8"?>
-<p:properties xmlns:p="http://schemas.microsoft.com/office/2006/metadata/properties" xmlns:xsi="http://www.w3.org/2001/XMLSchema-instance" xmlns:pc="http://schemas.microsoft.com/office/infopath/2007/PartnerControls">
-  <documentManagement>
-    <Document_x0020_Notes xmlns="2906fbf8-e47d-4c21-be87-cb09cf1c70cb">DO NOT EDIT. DOWNLOAD FIRST.</Document_x0020_Notes>
-    <FAQs xmlns="2906fbf8-e47d-4c21-be87-cb09cf1c70cb"/>
-    <TaxCatchAll xmlns="c30e2885-58e1-4e94-9dc7-f83158e7ef28" xsi:nil="true"/>
-    <lcf76f155ced4ddcb4097134ff3c332f xmlns="2906fbf8-e47d-4c21-be87-cb09cf1c70cb">
-      <Terms xmlns="http://schemas.microsoft.com/office/infopath/2007/PartnerControls"/>
-    </lcf76f155ced4ddcb4097134ff3c332f>
-    <SharedWithUsers xmlns="cd7196b5-af4d-4b5a-ba66-d723b2d8b01e">
-      <UserInfo>
-        <DisplayName>Simon Mishricky</DisplayName>
-        <AccountId>7743</AccountId>
-        <AccountType/>
-      </UserInfo>
-    </SharedWithUsers>
-  </documentManagement>
-</p:properties>
-</file>
-
-<file path=customXml/item3.xml><?xml version="1.0" encoding="utf-8"?>
 <ct:contentTypeSchema xmlns:ct="http://schemas.microsoft.com/office/2006/metadata/contentType" xmlns:ma="http://schemas.microsoft.com/office/2006/metadata/properties/metaAttributes" ct:_="" ma:_="" ma:contentTypeName="Document" ma:contentTypeID="0x010100EF009AC5283E95468D41B3B02A942082" ma:contentTypeVersion="18" ma:contentTypeDescription="Create a new document." ma:contentTypeScope="" ma:versionID="df342da6074ddaf222b98670cd88df63">
   <xsd:schema xmlns:xsd="http://www.w3.org/2001/XMLSchema" xmlns:xs="http://www.w3.org/2001/XMLSchema" xmlns:p="http://schemas.microsoft.com/office/2006/metadata/properties" xmlns:ns2="2906fbf8-e47d-4c21-be87-cb09cf1c70cb" xmlns:ns3="cd7196b5-af4d-4b5a-ba66-d723b2d8b01e" xmlns:ns4="c30e2885-58e1-4e94-9dc7-f83158e7ef28" targetNamespace="http://schemas.microsoft.com/office/2006/metadata/properties" ma:root="true" ma:fieldsID="6e4e19e9d36c91e495a51a1636f4d0b6" ns2:_="" ns3:_="" ns4:_="">
     <xsd:import namespace="2906fbf8-e47d-4c21-be87-cb09cf1c70cb"/>
@@ -25983,10 +25853,51 @@
 </ct:contentTypeSchema>
 </file>
 
+<file path=customXml/item2.xml><?xml version="1.0" encoding="utf-8"?>
+<p:properties xmlns:p="http://schemas.microsoft.com/office/2006/metadata/properties" xmlns:xsi="http://www.w3.org/2001/XMLSchema-instance" xmlns:pc="http://schemas.microsoft.com/office/infopath/2007/PartnerControls">
+  <documentManagement>
+    <Document_x0020_Notes xmlns="2906fbf8-e47d-4c21-be87-cb09cf1c70cb">DO NOT EDIT. DOWNLOAD FIRST.</Document_x0020_Notes>
+    <FAQs xmlns="2906fbf8-e47d-4c21-be87-cb09cf1c70cb"/>
+    <TaxCatchAll xmlns="c30e2885-58e1-4e94-9dc7-f83158e7ef28" xsi:nil="true"/>
+    <lcf76f155ced4ddcb4097134ff3c332f xmlns="2906fbf8-e47d-4c21-be87-cb09cf1c70cb">
+      <Terms xmlns="http://schemas.microsoft.com/office/infopath/2007/PartnerControls"/>
+    </lcf76f155ced4ddcb4097134ff3c332f>
+    <SharedWithUsers xmlns="cd7196b5-af4d-4b5a-ba66-d723b2d8b01e">
+      <UserInfo>
+        <DisplayName>Simon Mishricky</DisplayName>
+        <AccountId>7743</AccountId>
+        <AccountType/>
+      </UserInfo>
+    </SharedWithUsers>
+  </documentManagement>
+</p:properties>
+</file>
+
+<file path=customXml/item3.xml><?xml version="1.0" encoding="utf-8"?>
+<?mso-contentType ?>
+<FormTemplates xmlns="http://schemas.microsoft.com/sharepoint/v3/contenttype/forms">
+  <Display>DocumentLibraryForm</Display>
+  <Edit>DocumentLibraryForm</Edit>
+  <New>DocumentLibraryForm</New>
+</FormTemplates>
+</file>
+
 <file path=customXml/itemProps1.xml><?xml version="1.0" encoding="utf-8"?>
-<ds:datastoreItem xmlns:ds="http://schemas.openxmlformats.org/officeDocument/2006/customXml" ds:itemID="{D242CD11-9905-45C0-AA8E-EE5B79DEFBE2}">
+<ds:datastoreItem xmlns:ds="http://schemas.openxmlformats.org/officeDocument/2006/customXml" ds:itemID="{5AA5ED56-7671-4508-8E27-20ACB9C8341A}">
   <ds:schemaRefs>
-    <ds:schemaRef ds:uri="http://schemas.microsoft.com/sharepoint/v3/contenttype/forms"/>
+    <ds:schemaRef ds:uri="http://schemas.microsoft.com/office/2006/metadata/contentType"/>
+    <ds:schemaRef ds:uri="http://schemas.microsoft.com/office/2006/metadata/properties/metaAttributes"/>
+    <ds:schemaRef ds:uri="http://www.w3.org/2001/XMLSchema"/>
+    <ds:schemaRef ds:uri="http://schemas.microsoft.com/office/2006/metadata/properties"/>
+    <ds:schemaRef ds:uri="2906fbf8-e47d-4c21-be87-cb09cf1c70cb"/>
+    <ds:schemaRef ds:uri="cd7196b5-af4d-4b5a-ba66-d723b2d8b01e"/>
+    <ds:schemaRef ds:uri="c30e2885-58e1-4e94-9dc7-f83158e7ef28"/>
+    <ds:schemaRef ds:uri="http://schemas.microsoft.com/office/2006/documentManagement/types"/>
+    <ds:schemaRef ds:uri="http://schemas.microsoft.com/office/infopath/2007/PartnerControls"/>
+    <ds:schemaRef ds:uri="http://schemas.openxmlformats.org/package/2006/metadata/core-properties"/>
+    <ds:schemaRef ds:uri="http://purl.org/dc/elements/1.1/"/>
+    <ds:schemaRef ds:uri="http://purl.org/dc/terms/"/>
+    <ds:schemaRef ds:uri="http://schemas.microsoft.com/internal/obd"/>
   </ds:schemaRefs>
 </ds:datastoreItem>
 </file>
@@ -26010,21 +25921,9 @@
 </file>
 
 <file path=customXml/itemProps3.xml><?xml version="1.0" encoding="utf-8"?>
-<ds:datastoreItem xmlns:ds="http://schemas.openxmlformats.org/officeDocument/2006/customXml" ds:itemID="{5AA5ED56-7671-4508-8E27-20ACB9C8341A}">
+<ds:datastoreItem xmlns:ds="http://schemas.openxmlformats.org/officeDocument/2006/customXml" ds:itemID="{D242CD11-9905-45C0-AA8E-EE5B79DEFBE2}">
   <ds:schemaRefs>
-    <ds:schemaRef ds:uri="http://schemas.microsoft.com/office/2006/metadata/contentType"/>
-    <ds:schemaRef ds:uri="http://schemas.microsoft.com/office/2006/metadata/properties/metaAttributes"/>
-    <ds:schemaRef ds:uri="http://www.w3.org/2001/XMLSchema"/>
-    <ds:schemaRef ds:uri="http://schemas.microsoft.com/office/2006/metadata/properties"/>
-    <ds:schemaRef ds:uri="2906fbf8-e47d-4c21-be87-cb09cf1c70cb"/>
-    <ds:schemaRef ds:uri="cd7196b5-af4d-4b5a-ba66-d723b2d8b01e"/>
-    <ds:schemaRef ds:uri="c30e2885-58e1-4e94-9dc7-f83158e7ef28"/>
-    <ds:schemaRef ds:uri="http://schemas.microsoft.com/office/2006/documentManagement/types"/>
-    <ds:schemaRef ds:uri="http://schemas.microsoft.com/office/infopath/2007/PartnerControls"/>
-    <ds:schemaRef ds:uri="http://schemas.openxmlformats.org/package/2006/metadata/core-properties"/>
-    <ds:schemaRef ds:uri="http://purl.org/dc/elements/1.1/"/>
-    <ds:schemaRef ds:uri="http://purl.org/dc/terms/"/>
-    <ds:schemaRef ds:uri="http://schemas.microsoft.com/internal/obd"/>
+    <ds:schemaRef ds:uri="http://schemas.microsoft.com/sharepoint/v3/contenttype/forms"/>
   </ds:schemaRefs>
 </ds:datastoreItem>
 </file>
</xml_diff>